<commit_message>
formatting slides and editing slides
</commit_message>
<xml_diff>
--- a/slides for class/JS_Week4_Slides.pptx
+++ b/slides for class/JS_Week4_Slides.pptx
@@ -2,28 +2,28 @@
 <file path=ppt/presentation.xml><?xml version="1.0" encoding="utf-8"?>
 <p:presentation xmlns:a="http://schemas.openxmlformats.org/drawingml/2006/main" xmlns:r="http://schemas.openxmlformats.org/officeDocument/2006/relationships" xmlns:p="http://schemas.openxmlformats.org/presentationml/2006/main" saveSubsetFonts="1" autoCompressPictures="0">
   <p:sldMasterIdLst>
-    <p:sldMasterId id="2147483648" r:id="rId1"/>
+    <p:sldMasterId id="2147483744" r:id="rId1"/>
   </p:sldMasterIdLst>
   <p:sldIdLst>
-    <p:sldId id="256" r:id="rId7"/>
-    <p:sldId id="257" r:id="rId8"/>
-    <p:sldId id="258" r:id="rId9"/>
-    <p:sldId id="259" r:id="rId10"/>
-    <p:sldId id="260" r:id="rId11"/>
-    <p:sldId id="261" r:id="rId12"/>
-    <p:sldId id="262" r:id="rId13"/>
-    <p:sldId id="263" r:id="rId14"/>
-    <p:sldId id="264" r:id="rId15"/>
-    <p:sldId id="265" r:id="rId16"/>
-    <p:sldId id="266" r:id="rId17"/>
-    <p:sldId id="267" r:id="rId18"/>
-    <p:sldId id="268" r:id="rId19"/>
-    <p:sldId id="269" r:id="rId20"/>
-    <p:sldId id="270" r:id="rId21"/>
-    <p:sldId id="271" r:id="rId22"/>
-    <p:sldId id="272" r:id="rId23"/>
-    <p:sldId id="273" r:id="rId24"/>
-    <p:sldId id="274" r:id="rId25"/>
+    <p:sldId id="256" r:id="rId2"/>
+    <p:sldId id="257" r:id="rId3"/>
+    <p:sldId id="258" r:id="rId4"/>
+    <p:sldId id="259" r:id="rId5"/>
+    <p:sldId id="260" r:id="rId6"/>
+    <p:sldId id="261" r:id="rId7"/>
+    <p:sldId id="262" r:id="rId8"/>
+    <p:sldId id="263" r:id="rId9"/>
+    <p:sldId id="264" r:id="rId10"/>
+    <p:sldId id="265" r:id="rId11"/>
+    <p:sldId id="266" r:id="rId12"/>
+    <p:sldId id="267" r:id="rId13"/>
+    <p:sldId id="268" r:id="rId14"/>
+    <p:sldId id="269" r:id="rId15"/>
+    <p:sldId id="270" r:id="rId16"/>
+    <p:sldId id="271" r:id="rId17"/>
+    <p:sldId id="272" r:id="rId18"/>
+    <p:sldId id="273" r:id="rId19"/>
+    <p:sldId id="274" r:id="rId20"/>
   </p:sldIdLst>
   <p:sldSz cx="9144000" cy="6858000" type="screen4x3"/>
   <p:notesSz cx="6858000" cy="9144000"/>
@@ -122,6 +122,22 @@
       </a:defRPr>
     </a:lvl9pPr>
   </p:defaultTextStyle>
+  <p:extLst>
+    <p:ext uri="{EFAFB233-063F-42B5-8137-9DF3F51BA10A}">
+      <p15:sldGuideLst xmlns:p15="http://schemas.microsoft.com/office/powerpoint/2012/main">
+        <p15:guide id="1" orient="horz" pos="2160">
+          <p15:clr>
+            <a:srgbClr val="A4A3A4"/>
+          </p15:clr>
+        </p15:guide>
+        <p15:guide id="2" pos="2880">
+          <p15:clr>
+            <a:srgbClr val="A4A3A4"/>
+          </p15:clr>
+        </p15:guide>
+      </p15:sldGuideLst>
+    </p:ext>
+  </p:extLst>
 </p:presentation>
 </file>
 
@@ -154,19 +170,25 @@
         </p:nvSpPr>
         <p:spPr>
           <a:xfrm>
-            <a:off x="685800" y="2130425"/>
-            <a:ext cx="7772400" cy="1470025"/>
+            <a:off x="2396319" y="802299"/>
+            <a:ext cx="5618515" cy="2541431"/>
           </a:xfrm>
         </p:spPr>
         <p:txBody>
-          <a:bodyPr/>
-          <a:lstStyle/>
-          <a:p>
-            <a:r>
-              <a:rPr lang="en-US" smtClean="0"/>
+          <a:bodyPr bIns="0" anchor="b">
+            <a:normAutofit/>
+          </a:bodyPr>
+          <a:lstStyle>
+            <a:lvl1pPr algn="l">
+              <a:defRPr sz="5400"/>
+            </a:lvl1pPr>
+          </a:lstStyle>
+          <a:p>
+            <a:r>
+              <a:rPr lang="en-US"/>
               <a:t>Click to edit Master title style</a:t>
             </a:r>
-            <a:endParaRPr lang="en-US"/>
+            <a:endParaRPr lang="en-US" dirty="0"/>
           </a:p>
         </p:txBody>
       </p:sp>
@@ -182,110 +204,62 @@
         </p:nvSpPr>
         <p:spPr>
           <a:xfrm>
-            <a:off x="1371600" y="3886200"/>
-            <a:ext cx="6400800" cy="1752600"/>
+            <a:off x="2396319" y="3531205"/>
+            <a:ext cx="5618515" cy="977621"/>
           </a:xfrm>
         </p:spPr>
         <p:txBody>
-          <a:bodyPr/>
+          <a:bodyPr tIns="91440" bIns="91440">
+            <a:normAutofit/>
+          </a:bodyPr>
           <a:lstStyle>
-            <a:lvl1pPr marL="0" indent="0" algn="ctr">
-              <a:buNone/>
-              <a:defRPr>
+            <a:lvl1pPr marL="0" indent="0" algn="l">
+              <a:buNone/>
+              <a:defRPr sz="1600" b="0" cap="all" baseline="0">
                 <a:solidFill>
-                  <a:schemeClr val="tx1">
-                    <a:tint val="75000"/>
-                  </a:schemeClr>
+                  <a:schemeClr val="tx1"/>
                 </a:solidFill>
               </a:defRPr>
             </a:lvl1pPr>
-            <a:lvl2pPr marL="457200" indent="0" algn="ctr">
-              <a:buNone/>
-              <a:defRPr>
-                <a:solidFill>
-                  <a:schemeClr val="tx1">
-                    <a:tint val="75000"/>
-                  </a:schemeClr>
-                </a:solidFill>
-              </a:defRPr>
+            <a:lvl2pPr marL="342900" indent="0" algn="ctr">
+              <a:buNone/>
+              <a:defRPr sz="1500"/>
             </a:lvl2pPr>
-            <a:lvl3pPr marL="914400" indent="0" algn="ctr">
-              <a:buNone/>
-              <a:defRPr>
-                <a:solidFill>
-                  <a:schemeClr val="tx1">
-                    <a:tint val="75000"/>
-                  </a:schemeClr>
-                </a:solidFill>
-              </a:defRPr>
+            <a:lvl3pPr marL="685800" indent="0" algn="ctr">
+              <a:buNone/>
+              <a:defRPr sz="1350"/>
             </a:lvl3pPr>
-            <a:lvl4pPr marL="1371600" indent="0" algn="ctr">
-              <a:buNone/>
-              <a:defRPr>
-                <a:solidFill>
-                  <a:schemeClr val="tx1">
-                    <a:tint val="75000"/>
-                  </a:schemeClr>
-                </a:solidFill>
-              </a:defRPr>
+            <a:lvl4pPr marL="1028700" indent="0" algn="ctr">
+              <a:buNone/>
+              <a:defRPr sz="1200"/>
             </a:lvl4pPr>
-            <a:lvl5pPr marL="1828800" indent="0" algn="ctr">
-              <a:buNone/>
-              <a:defRPr>
-                <a:solidFill>
-                  <a:schemeClr val="tx1">
-                    <a:tint val="75000"/>
-                  </a:schemeClr>
-                </a:solidFill>
-              </a:defRPr>
+            <a:lvl5pPr marL="1371600" indent="0" algn="ctr">
+              <a:buNone/>
+              <a:defRPr sz="1200"/>
             </a:lvl5pPr>
-            <a:lvl6pPr marL="2286000" indent="0" algn="ctr">
-              <a:buNone/>
-              <a:defRPr>
-                <a:solidFill>
-                  <a:schemeClr val="tx1">
-                    <a:tint val="75000"/>
-                  </a:schemeClr>
-                </a:solidFill>
-              </a:defRPr>
+            <a:lvl6pPr marL="1714500" indent="0" algn="ctr">
+              <a:buNone/>
+              <a:defRPr sz="1200"/>
             </a:lvl6pPr>
-            <a:lvl7pPr marL="2743200" indent="0" algn="ctr">
-              <a:buNone/>
-              <a:defRPr>
-                <a:solidFill>
-                  <a:schemeClr val="tx1">
-                    <a:tint val="75000"/>
-                  </a:schemeClr>
-                </a:solidFill>
-              </a:defRPr>
+            <a:lvl7pPr marL="2057400" indent="0" algn="ctr">
+              <a:buNone/>
+              <a:defRPr sz="1200"/>
             </a:lvl7pPr>
-            <a:lvl8pPr marL="3200400" indent="0" algn="ctr">
-              <a:buNone/>
-              <a:defRPr>
-                <a:solidFill>
-                  <a:schemeClr val="tx1">
-                    <a:tint val="75000"/>
-                  </a:schemeClr>
-                </a:solidFill>
-              </a:defRPr>
+            <a:lvl8pPr marL="2400300" indent="0" algn="ctr">
+              <a:buNone/>
+              <a:defRPr sz="1200"/>
             </a:lvl8pPr>
-            <a:lvl9pPr marL="3657600" indent="0" algn="ctr">
-              <a:buNone/>
-              <a:defRPr>
-                <a:solidFill>
-                  <a:schemeClr val="tx1">
-                    <a:tint val="75000"/>
-                  </a:schemeClr>
-                </a:solidFill>
-              </a:defRPr>
+            <a:lvl9pPr marL="2743200" indent="0" algn="ctr">
+              <a:buNone/>
+              <a:defRPr sz="1200"/>
             </a:lvl9pPr>
           </a:lstStyle>
           <a:p>
             <a:r>
-              <a:rPr lang="en-US" smtClean="0"/>
+              <a:rPr lang="en-US"/>
               <a:t>Click to edit Master subtitle style</a:t>
             </a:r>
-            <a:endParaRPr lang="en-US"/>
+            <a:endParaRPr lang="en-US" dirty="0"/>
           </a:p>
         </p:txBody>
       </p:sp>
@@ -306,7 +280,7 @@
           <a:p>
             <a:fld id="{5BCAD085-E8A6-8845-BD4E-CB4CCA059FC4}" type="datetimeFigureOut">
               <a:rPr lang="en-US" smtClean="0"/>
-              <a:t>1/27/13</a:t>
+              <a:t>9/26/25</a:t>
             </a:fld>
             <a:endParaRPr lang="en-US"/>
           </a:p>
@@ -322,7 +296,12 @@
             <p:ph type="ftr" sz="quarter" idx="11"/>
           </p:nvPr>
         </p:nvSpPr>
-        <p:spPr/>
+        <p:spPr>
+          <a:xfrm>
+            <a:off x="2396319" y="329308"/>
+            <a:ext cx="3086292" cy="309201"/>
+          </a:xfrm>
+        </p:spPr>
         <p:txBody>
           <a:bodyPr/>
           <a:lstStyle/>
@@ -341,7 +320,12 @@
             <p:ph type="sldNum" sz="quarter" idx="12"/>
           </p:nvPr>
         </p:nvSpPr>
-        <p:spPr/>
+        <p:spPr>
+          <a:xfrm>
+            <a:off x="1434703" y="798973"/>
+            <a:ext cx="802005" cy="503578"/>
+          </a:xfrm>
+        </p:spPr>
         <p:txBody>
           <a:bodyPr/>
           <a:lstStyle/>
@@ -354,10 +338,41 @@
           </a:p>
         </p:txBody>
       </p:sp>
+      <p:cxnSp>
+        <p:nvCxnSpPr>
+          <p:cNvPr id="15" name="Straight Connector 14"/>
+          <p:cNvCxnSpPr/>
+          <p:nvPr/>
+        </p:nvCxnSpPr>
+        <p:spPr>
+          <a:xfrm>
+            <a:off x="2396319" y="3528542"/>
+            <a:ext cx="5618515" cy="0"/>
+          </a:xfrm>
+          <a:prstGeom prst="line">
+            <a:avLst/>
+          </a:prstGeom>
+          <a:ln w="31750"/>
+        </p:spPr>
+        <p:style>
+          <a:lnRef idx="3">
+            <a:schemeClr val="accent1"/>
+          </a:lnRef>
+          <a:fillRef idx="0">
+            <a:schemeClr val="accent1"/>
+          </a:fillRef>
+          <a:effectRef idx="2">
+            <a:schemeClr val="accent1"/>
+          </a:effectRef>
+          <a:fontRef idx="minor">
+            <a:schemeClr val="tx1"/>
+          </a:fontRef>
+        </p:style>
+      </p:cxnSp>
     </p:spTree>
     <p:extLst>
       <p:ext uri="{BB962C8B-B14F-4D97-AF65-F5344CB8AC3E}">
-        <p14:creationId xmlns:p14="http://schemas.microsoft.com/office/powerpoint/2010/main" val="3168075583"/>
+        <p14:creationId xmlns:p14="http://schemas.microsoft.com/office/powerpoint/2010/main" val="4220421926"/>
       </p:ext>
     </p:extLst>
   </p:cSld>
@@ -384,6 +399,37 @@
           <a:chExt cx="0" cy="0"/>
         </a:xfrm>
       </p:grpSpPr>
+      <p:cxnSp>
+        <p:nvCxnSpPr>
+          <p:cNvPr id="33" name="Straight Connector 32"/>
+          <p:cNvCxnSpPr/>
+          <p:nvPr/>
+        </p:nvCxnSpPr>
+        <p:spPr>
+          <a:xfrm>
+            <a:off x="1443491" y="1847088"/>
+            <a:ext cx="6571343" cy="0"/>
+          </a:xfrm>
+          <a:prstGeom prst="line">
+            <a:avLst/>
+          </a:prstGeom>
+          <a:ln w="31750"/>
+        </p:spPr>
+        <p:style>
+          <a:lnRef idx="3">
+            <a:schemeClr val="accent1"/>
+          </a:lnRef>
+          <a:fillRef idx="0">
+            <a:schemeClr val="accent1"/>
+          </a:fillRef>
+          <a:effectRef idx="2">
+            <a:schemeClr val="accent1"/>
+          </a:effectRef>
+          <a:fontRef idx="minor">
+            <a:schemeClr val="tx1"/>
+          </a:fontRef>
+        </p:style>
+      </p:cxnSp>
       <p:sp>
         <p:nvSpPr>
           <p:cNvPr id="2" name="Title 1"/>
@@ -400,10 +446,10 @@
           <a:lstStyle/>
           <a:p>
             <a:r>
-              <a:rPr lang="en-US" smtClean="0"/>
+              <a:rPr lang="en-US"/>
               <a:t>Click to edit Master title style</a:t>
             </a:r>
-            <a:endParaRPr lang="en-US"/>
+            <a:endParaRPr lang="en-US" dirty="0"/>
           </a:p>
         </p:txBody>
       </p:sp>
@@ -424,38 +470,38 @@
           <a:p>
             <a:pPr lvl="0"/>
             <a:r>
-              <a:rPr lang="en-US" smtClean="0"/>
+              <a:rPr lang="en-US"/>
               <a:t>Click to edit Master text styles</a:t>
             </a:r>
           </a:p>
           <a:p>
             <a:pPr lvl="1"/>
             <a:r>
-              <a:rPr lang="en-US" smtClean="0"/>
+              <a:rPr lang="en-US"/>
               <a:t>Second level</a:t>
             </a:r>
           </a:p>
           <a:p>
             <a:pPr lvl="2"/>
             <a:r>
-              <a:rPr lang="en-US" smtClean="0"/>
+              <a:rPr lang="en-US"/>
               <a:t>Third level</a:t>
             </a:r>
           </a:p>
           <a:p>
             <a:pPr lvl="3"/>
             <a:r>
-              <a:rPr lang="en-US" smtClean="0"/>
+              <a:rPr lang="en-US"/>
               <a:t>Fourth level</a:t>
             </a:r>
           </a:p>
           <a:p>
             <a:pPr lvl="4"/>
             <a:r>
-              <a:rPr lang="en-US" smtClean="0"/>
+              <a:rPr lang="en-US"/>
               <a:t>Fifth level</a:t>
             </a:r>
-            <a:endParaRPr lang="en-US"/>
+            <a:endParaRPr lang="en-US" dirty="0"/>
           </a:p>
         </p:txBody>
       </p:sp>
@@ -476,7 +522,7 @@
           <a:p>
             <a:fld id="{5BCAD085-E8A6-8845-BD4E-CB4CCA059FC4}" type="datetimeFigureOut">
               <a:rPr lang="en-US" smtClean="0"/>
-              <a:t>1/27/13</a:t>
+              <a:t>9/26/25</a:t>
             </a:fld>
             <a:endParaRPr lang="en-US"/>
           </a:p>
@@ -527,7 +573,7 @@
     </p:spTree>
     <p:extLst>
       <p:ext uri="{BB962C8B-B14F-4D97-AF65-F5344CB8AC3E}">
-        <p14:creationId xmlns:p14="http://schemas.microsoft.com/office/powerpoint/2010/main" val="2910927964"/>
+        <p14:creationId xmlns:p14="http://schemas.microsoft.com/office/powerpoint/2010/main" val="2587981923"/>
       </p:ext>
     </p:extLst>
   </p:cSld>
@@ -566,19 +612,23 @@
         </p:nvSpPr>
         <p:spPr>
           <a:xfrm>
-            <a:off x="6629400" y="274638"/>
-            <a:ext cx="2057400" cy="5851525"/>
+            <a:off x="6918028" y="798974"/>
+            <a:ext cx="1103027" cy="4659889"/>
           </a:xfrm>
         </p:spPr>
         <p:txBody>
           <a:bodyPr vert="eaVert"/>
-          <a:lstStyle/>
-          <a:p>
-            <a:r>
-              <a:rPr lang="en-US" smtClean="0"/>
+          <a:lstStyle>
+            <a:lvl1pPr algn="l">
+              <a:defRPr/>
+            </a:lvl1pPr>
+          </a:lstStyle>
+          <a:p>
+            <a:r>
+              <a:rPr lang="en-US"/>
               <a:t>Click to edit Master title style</a:t>
             </a:r>
-            <a:endParaRPr lang="en-US"/>
+            <a:endParaRPr lang="en-US" dirty="0"/>
           </a:p>
         </p:txBody>
       </p:sp>
@@ -594,8 +644,8 @@
         </p:nvSpPr>
         <p:spPr>
           <a:xfrm>
-            <a:off x="457200" y="274638"/>
-            <a:ext cx="6019800" cy="5851525"/>
+            <a:off x="1443491" y="798974"/>
+            <a:ext cx="5301095" cy="4659889"/>
           </a:xfrm>
         </p:spPr>
         <p:txBody>
@@ -604,38 +654,38 @@
           <a:p>
             <a:pPr lvl="0"/>
             <a:r>
-              <a:rPr lang="en-US" smtClean="0"/>
+              <a:rPr lang="en-US"/>
               <a:t>Click to edit Master text styles</a:t>
             </a:r>
           </a:p>
           <a:p>
             <a:pPr lvl="1"/>
             <a:r>
-              <a:rPr lang="en-US" smtClean="0"/>
+              <a:rPr lang="en-US"/>
               <a:t>Second level</a:t>
             </a:r>
           </a:p>
           <a:p>
             <a:pPr lvl="2"/>
             <a:r>
-              <a:rPr lang="en-US" smtClean="0"/>
+              <a:rPr lang="en-US"/>
               <a:t>Third level</a:t>
             </a:r>
           </a:p>
           <a:p>
             <a:pPr lvl="3"/>
             <a:r>
-              <a:rPr lang="en-US" smtClean="0"/>
+              <a:rPr lang="en-US"/>
               <a:t>Fourth level</a:t>
             </a:r>
           </a:p>
           <a:p>
             <a:pPr lvl="4"/>
             <a:r>
-              <a:rPr lang="en-US" smtClean="0"/>
+              <a:rPr lang="en-US"/>
               <a:t>Fifth level</a:t>
             </a:r>
-            <a:endParaRPr lang="en-US"/>
+            <a:endParaRPr lang="en-US" dirty="0"/>
           </a:p>
         </p:txBody>
       </p:sp>
@@ -656,7 +706,7 @@
           <a:p>
             <a:fld id="{5BCAD085-E8A6-8845-BD4E-CB4CCA059FC4}" type="datetimeFigureOut">
               <a:rPr lang="en-US" smtClean="0"/>
-              <a:t>1/27/13</a:t>
+              <a:t>9/26/25</a:t>
             </a:fld>
             <a:endParaRPr lang="en-US"/>
           </a:p>
@@ -704,10 +754,41 @@
           </a:p>
         </p:txBody>
       </p:sp>
+      <p:cxnSp>
+        <p:nvCxnSpPr>
+          <p:cNvPr id="15" name="Straight Connector 14"/>
+          <p:cNvCxnSpPr/>
+          <p:nvPr/>
+        </p:nvCxnSpPr>
+        <p:spPr>
+          <a:xfrm>
+            <a:off x="6918028" y="798974"/>
+            <a:ext cx="0" cy="4659889"/>
+          </a:xfrm>
+          <a:prstGeom prst="line">
+            <a:avLst/>
+          </a:prstGeom>
+          <a:ln w="31750"/>
+        </p:spPr>
+        <p:style>
+          <a:lnRef idx="3">
+            <a:schemeClr val="accent1"/>
+          </a:lnRef>
+          <a:fillRef idx="0">
+            <a:schemeClr val="accent1"/>
+          </a:fillRef>
+          <a:effectRef idx="2">
+            <a:schemeClr val="accent1"/>
+          </a:effectRef>
+          <a:fontRef idx="minor">
+            <a:schemeClr val="tx1"/>
+          </a:fontRef>
+        </p:style>
+      </p:cxnSp>
     </p:spTree>
     <p:extLst>
       <p:ext uri="{BB962C8B-B14F-4D97-AF65-F5344CB8AC3E}">
-        <p14:creationId xmlns:p14="http://schemas.microsoft.com/office/powerpoint/2010/main" val="3612223792"/>
+        <p14:creationId xmlns:p14="http://schemas.microsoft.com/office/powerpoint/2010/main" val="1097170983"/>
       </p:ext>
     </p:extLst>
   </p:cSld>
@@ -750,10 +831,10 @@
           <a:lstStyle/>
           <a:p>
             <a:r>
-              <a:rPr lang="en-US" smtClean="0"/>
+              <a:rPr lang="en-US"/>
               <a:t>Click to edit Master title style</a:t>
             </a:r>
-            <a:endParaRPr lang="en-US"/>
+            <a:endParaRPr lang="en-US" dirty="0"/>
           </a:p>
         </p:txBody>
       </p:sp>
@@ -769,43 +850,43 @@
         </p:nvSpPr>
         <p:spPr/>
         <p:txBody>
-          <a:bodyPr/>
+          <a:bodyPr anchor="t"/>
           <a:lstStyle/>
           <a:p>
             <a:pPr lvl="0"/>
             <a:r>
-              <a:rPr lang="en-US" smtClean="0"/>
+              <a:rPr lang="en-US"/>
               <a:t>Click to edit Master text styles</a:t>
             </a:r>
           </a:p>
           <a:p>
             <a:pPr lvl="1"/>
             <a:r>
-              <a:rPr lang="en-US" smtClean="0"/>
+              <a:rPr lang="en-US"/>
               <a:t>Second level</a:t>
             </a:r>
           </a:p>
           <a:p>
             <a:pPr lvl="2"/>
             <a:r>
-              <a:rPr lang="en-US" smtClean="0"/>
+              <a:rPr lang="en-US"/>
               <a:t>Third level</a:t>
             </a:r>
           </a:p>
           <a:p>
             <a:pPr lvl="3"/>
             <a:r>
-              <a:rPr lang="en-US" smtClean="0"/>
+              <a:rPr lang="en-US"/>
               <a:t>Fourth level</a:t>
             </a:r>
           </a:p>
           <a:p>
             <a:pPr lvl="4"/>
             <a:r>
-              <a:rPr lang="en-US" smtClean="0"/>
+              <a:rPr lang="en-US"/>
               <a:t>Fifth level</a:t>
             </a:r>
-            <a:endParaRPr lang="en-US"/>
+            <a:endParaRPr lang="en-US" dirty="0"/>
           </a:p>
         </p:txBody>
       </p:sp>
@@ -826,7 +907,7 @@
           <a:p>
             <a:fld id="{5BCAD085-E8A6-8845-BD4E-CB4CCA059FC4}" type="datetimeFigureOut">
               <a:rPr lang="en-US" smtClean="0"/>
-              <a:t>1/27/13</a:t>
+              <a:t>9/26/25</a:t>
             </a:fld>
             <a:endParaRPr lang="en-US"/>
           </a:p>
@@ -874,10 +955,41 @@
           </a:p>
         </p:txBody>
       </p:sp>
+      <p:cxnSp>
+        <p:nvCxnSpPr>
+          <p:cNvPr id="33" name="Straight Connector 32"/>
+          <p:cNvCxnSpPr/>
+          <p:nvPr/>
+        </p:nvCxnSpPr>
+        <p:spPr>
+          <a:xfrm>
+            <a:off x="1443491" y="1847088"/>
+            <a:ext cx="6571343" cy="0"/>
+          </a:xfrm>
+          <a:prstGeom prst="line">
+            <a:avLst/>
+          </a:prstGeom>
+          <a:ln w="31750"/>
+        </p:spPr>
+        <p:style>
+          <a:lnRef idx="3">
+            <a:schemeClr val="accent1"/>
+          </a:lnRef>
+          <a:fillRef idx="0">
+            <a:schemeClr val="accent1"/>
+          </a:fillRef>
+          <a:effectRef idx="2">
+            <a:schemeClr val="accent1"/>
+          </a:effectRef>
+          <a:fontRef idx="minor">
+            <a:schemeClr val="tx1"/>
+          </a:fontRef>
+        </p:style>
+      </p:cxnSp>
     </p:spTree>
     <p:extLst>
       <p:ext uri="{BB962C8B-B14F-4D97-AF65-F5344CB8AC3E}">
-        <p14:creationId xmlns:p14="http://schemas.microsoft.com/office/powerpoint/2010/main" val="2614314258"/>
+        <p14:creationId xmlns:p14="http://schemas.microsoft.com/office/powerpoint/2010/main" val="2224489379"/>
       </p:ext>
     </p:extLst>
   </p:cSld>
@@ -916,23 +1028,25 @@
         </p:nvSpPr>
         <p:spPr>
           <a:xfrm>
-            <a:off x="722313" y="4406900"/>
-            <a:ext cx="7772400" cy="1362075"/>
+            <a:off x="1443491" y="1756130"/>
+            <a:ext cx="5617002" cy="1887950"/>
           </a:xfrm>
         </p:spPr>
         <p:txBody>
-          <a:bodyPr anchor="t"/>
+          <a:bodyPr anchor="b">
+            <a:normAutofit/>
+          </a:bodyPr>
           <a:lstStyle>
             <a:lvl1pPr algn="l">
-              <a:defRPr sz="4000" b="1" cap="all"/>
+              <a:defRPr sz="3200"/>
             </a:lvl1pPr>
           </a:lstStyle>
           <a:p>
             <a:r>
-              <a:rPr lang="en-US" smtClean="0"/>
+              <a:rPr lang="en-US"/>
               <a:t>Click to edit Master title style</a:t>
             </a:r>
-            <a:endParaRPr lang="en-US"/>
+            <a:endParaRPr lang="en-US" dirty="0"/>
           </a:p>
         </p:txBody>
       </p:sp>
@@ -948,26 +1062,26 @@
         </p:nvSpPr>
         <p:spPr>
           <a:xfrm>
-            <a:off x="722313" y="2906713"/>
-            <a:ext cx="7772400" cy="1500187"/>
+            <a:off x="1443492" y="3806196"/>
+            <a:ext cx="5617002" cy="1012929"/>
           </a:xfrm>
         </p:spPr>
         <p:txBody>
-          <a:bodyPr anchor="b"/>
+          <a:bodyPr tIns="91440">
+            <a:normAutofit/>
+          </a:bodyPr>
           <a:lstStyle>
-            <a:lvl1pPr marL="0" indent="0">
-              <a:buNone/>
-              <a:defRPr sz="2000">
+            <a:lvl1pPr marL="0" indent="0" algn="l">
+              <a:buNone/>
+              <a:defRPr sz="1800">
                 <a:solidFill>
-                  <a:schemeClr val="tx1">
-                    <a:tint val="75000"/>
-                  </a:schemeClr>
+                  <a:schemeClr val="tx1"/>
                 </a:solidFill>
               </a:defRPr>
             </a:lvl1pPr>
-            <a:lvl2pPr marL="457200" indent="0">
-              <a:buNone/>
-              <a:defRPr sz="1800">
+            <a:lvl2pPr marL="342900" indent="0">
+              <a:buNone/>
+              <a:defRPr sz="1500">
                 <a:solidFill>
                   <a:schemeClr val="tx1">
                     <a:tint val="75000"/>
@@ -975,9 +1089,9 @@
                 </a:solidFill>
               </a:defRPr>
             </a:lvl2pPr>
-            <a:lvl3pPr marL="914400" indent="0">
-              <a:buNone/>
-              <a:defRPr sz="1600">
+            <a:lvl3pPr marL="685800" indent="0">
+              <a:buNone/>
+              <a:defRPr sz="1350">
                 <a:solidFill>
                   <a:schemeClr val="tx1">
                     <a:tint val="75000"/>
@@ -985,9 +1099,9 @@
                 </a:solidFill>
               </a:defRPr>
             </a:lvl3pPr>
-            <a:lvl4pPr marL="1371600" indent="0">
-              <a:buNone/>
-              <a:defRPr sz="1400">
+            <a:lvl4pPr marL="1028700" indent="0">
+              <a:buNone/>
+              <a:defRPr sz="1200">
                 <a:solidFill>
                   <a:schemeClr val="tx1">
                     <a:tint val="75000"/>
@@ -995,9 +1109,9 @@
                 </a:solidFill>
               </a:defRPr>
             </a:lvl4pPr>
-            <a:lvl5pPr marL="1828800" indent="0">
-              <a:buNone/>
-              <a:defRPr sz="1400">
+            <a:lvl5pPr marL="1371600" indent="0">
+              <a:buNone/>
+              <a:defRPr sz="1200">
                 <a:solidFill>
                   <a:schemeClr val="tx1">
                     <a:tint val="75000"/>
@@ -1005,9 +1119,9 @@
                 </a:solidFill>
               </a:defRPr>
             </a:lvl5pPr>
-            <a:lvl6pPr marL="2286000" indent="0">
-              <a:buNone/>
-              <a:defRPr sz="1400">
+            <a:lvl6pPr marL="1714500" indent="0">
+              <a:buNone/>
+              <a:defRPr sz="1200">
                 <a:solidFill>
                   <a:schemeClr val="tx1">
                     <a:tint val="75000"/>
@@ -1015,9 +1129,9 @@
                 </a:solidFill>
               </a:defRPr>
             </a:lvl6pPr>
-            <a:lvl7pPr marL="2743200" indent="0">
-              <a:buNone/>
-              <a:defRPr sz="1400">
+            <a:lvl7pPr marL="2057400" indent="0">
+              <a:buNone/>
+              <a:defRPr sz="1200">
                 <a:solidFill>
                   <a:schemeClr val="tx1">
                     <a:tint val="75000"/>
@@ -1025,9 +1139,9 @@
                 </a:solidFill>
               </a:defRPr>
             </a:lvl7pPr>
-            <a:lvl8pPr marL="3200400" indent="0">
-              <a:buNone/>
-              <a:defRPr sz="1400">
+            <a:lvl8pPr marL="2400300" indent="0">
+              <a:buNone/>
+              <a:defRPr sz="1200">
                 <a:solidFill>
                   <a:schemeClr val="tx1">
                     <a:tint val="75000"/>
@@ -1035,9 +1149,9 @@
                 </a:solidFill>
               </a:defRPr>
             </a:lvl8pPr>
-            <a:lvl9pPr marL="3657600" indent="0">
-              <a:buNone/>
-              <a:defRPr sz="1400">
+            <a:lvl9pPr marL="2743200" indent="0">
+              <a:buNone/>
+              <a:defRPr sz="1200">
                 <a:solidFill>
                   <a:schemeClr val="tx1">
                     <a:tint val="75000"/>
@@ -1049,7 +1163,7 @@
           <a:p>
             <a:pPr lvl="0"/>
             <a:r>
-              <a:rPr lang="en-US" smtClean="0"/>
+              <a:rPr lang="en-US"/>
               <a:t>Click to edit Master text styles</a:t>
             </a:r>
           </a:p>
@@ -1072,7 +1186,7 @@
           <a:p>
             <a:fld id="{5BCAD085-E8A6-8845-BD4E-CB4CCA059FC4}" type="datetimeFigureOut">
               <a:rPr lang="en-US" smtClean="0"/>
-              <a:t>1/27/13</a:t>
+              <a:t>9/26/25</a:t>
             </a:fld>
             <a:endParaRPr lang="en-US"/>
           </a:p>
@@ -1120,10 +1234,41 @@
           </a:p>
         </p:txBody>
       </p:sp>
+      <p:cxnSp>
+        <p:nvCxnSpPr>
+          <p:cNvPr id="15" name="Straight Connector 14"/>
+          <p:cNvCxnSpPr/>
+          <p:nvPr/>
+        </p:nvCxnSpPr>
+        <p:spPr>
+          <a:xfrm>
+            <a:off x="1443491" y="3804985"/>
+            <a:ext cx="5617002" cy="0"/>
+          </a:xfrm>
+          <a:prstGeom prst="line">
+            <a:avLst/>
+          </a:prstGeom>
+          <a:ln w="31750"/>
+        </p:spPr>
+        <p:style>
+          <a:lnRef idx="3">
+            <a:schemeClr val="accent1"/>
+          </a:lnRef>
+          <a:fillRef idx="0">
+            <a:schemeClr val="accent1"/>
+          </a:fillRef>
+          <a:effectRef idx="2">
+            <a:schemeClr val="accent1"/>
+          </a:effectRef>
+          <a:fontRef idx="minor">
+            <a:schemeClr val="tx1"/>
+          </a:fontRef>
+        </p:style>
+      </p:cxnSp>
     </p:spTree>
     <p:extLst>
       <p:ext uri="{BB962C8B-B14F-4D97-AF65-F5344CB8AC3E}">
-        <p14:creationId xmlns:p14="http://schemas.microsoft.com/office/powerpoint/2010/main" val="960648375"/>
+        <p14:creationId xmlns:p14="http://schemas.microsoft.com/office/powerpoint/2010/main" val="4070015792"/>
       </p:ext>
     </p:extLst>
   </p:cSld>
@@ -1160,186 +1305,135 @@
             <p:ph type="title"/>
           </p:nvPr>
         </p:nvSpPr>
-        <p:spPr/>
-        <p:txBody>
-          <a:bodyPr/>
-          <a:lstStyle/>
-          <a:p>
-            <a:r>
-              <a:rPr lang="en-US" smtClean="0"/>
-              <a:t>Click to edit Master title style</a:t>
-            </a:r>
-            <a:endParaRPr lang="en-US"/>
-          </a:p>
-        </p:txBody>
-      </p:sp>
-      <p:sp>
-        <p:nvSpPr>
-          <p:cNvPr id="3" name="Content Placeholder 2"/>
-          <p:cNvSpPr>
-            <a:spLocks noGrp="1"/>
-          </p:cNvSpPr>
-          <p:nvPr>
-            <p:ph sz="half" idx="1"/>
-          </p:nvPr>
-        </p:nvSpPr>
         <p:spPr>
           <a:xfrm>
-            <a:off x="457200" y="1600200"/>
-            <a:ext cx="4038600" cy="4525963"/>
+            <a:off x="1443491" y="804890"/>
+            <a:ext cx="6571343" cy="1059305"/>
           </a:xfrm>
         </p:spPr>
         <p:txBody>
           <a:bodyPr/>
-          <a:lstStyle>
-            <a:lvl1pPr>
-              <a:defRPr sz="2800"/>
-            </a:lvl1pPr>
-            <a:lvl2pPr>
-              <a:defRPr sz="2400"/>
-            </a:lvl2pPr>
-            <a:lvl3pPr>
-              <a:defRPr sz="2000"/>
-            </a:lvl3pPr>
-            <a:lvl4pPr>
-              <a:defRPr sz="1800"/>
-            </a:lvl4pPr>
-            <a:lvl5pPr>
-              <a:defRPr sz="1800"/>
-            </a:lvl5pPr>
-            <a:lvl6pPr>
-              <a:defRPr sz="1800"/>
-            </a:lvl6pPr>
-            <a:lvl7pPr>
-              <a:defRPr sz="1800"/>
-            </a:lvl7pPr>
-            <a:lvl8pPr>
-              <a:defRPr sz="1800"/>
-            </a:lvl8pPr>
-            <a:lvl9pPr>
-              <a:defRPr sz="1800"/>
-            </a:lvl9pPr>
-          </a:lstStyle>
-          <a:p>
-            <a:pPr lvl="0"/>
-            <a:r>
-              <a:rPr lang="en-US" smtClean="0"/>
-              <a:t>Click to edit Master text styles</a:t>
-            </a:r>
-          </a:p>
-          <a:p>
-            <a:pPr lvl="1"/>
-            <a:r>
-              <a:rPr lang="en-US" smtClean="0"/>
-              <a:t>Second level</a:t>
-            </a:r>
-          </a:p>
-          <a:p>
-            <a:pPr lvl="2"/>
-            <a:r>
-              <a:rPr lang="en-US" smtClean="0"/>
-              <a:t>Third level</a:t>
-            </a:r>
-          </a:p>
-          <a:p>
-            <a:pPr lvl="3"/>
-            <a:r>
-              <a:rPr lang="en-US" smtClean="0"/>
-              <a:t>Fourth level</a:t>
-            </a:r>
-          </a:p>
-          <a:p>
-            <a:pPr lvl="4"/>
-            <a:r>
-              <a:rPr lang="en-US" smtClean="0"/>
-              <a:t>Fifth level</a:t>
-            </a:r>
-            <a:endParaRPr lang="en-US"/>
-          </a:p>
-        </p:txBody>
-      </p:sp>
-      <p:sp>
-        <p:nvSpPr>
-          <p:cNvPr id="4" name="Content Placeholder 3"/>
-          <p:cNvSpPr>
-            <a:spLocks noGrp="1"/>
-          </p:cNvSpPr>
-          <p:nvPr>
-            <p:ph sz="half" idx="2"/>
+          <a:lstStyle/>
+          <a:p>
+            <a:r>
+              <a:rPr lang="en-US"/>
+              <a:t>Click to edit Master title style</a:t>
+            </a:r>
+            <a:endParaRPr lang="en-US" dirty="0"/>
+          </a:p>
+        </p:txBody>
+      </p:sp>
+      <p:sp>
+        <p:nvSpPr>
+          <p:cNvPr id="3" name="Content Placeholder 2"/>
+          <p:cNvSpPr>
+            <a:spLocks noGrp="1"/>
+          </p:cNvSpPr>
+          <p:nvPr>
+            <p:ph sz="half" idx="1"/>
           </p:nvPr>
         </p:nvSpPr>
         <p:spPr>
           <a:xfrm>
-            <a:off x="4648200" y="1600200"/>
-            <a:ext cx="4038600" cy="4525963"/>
+            <a:off x="1443490" y="2013936"/>
+            <a:ext cx="3125871" cy="3437560"/>
           </a:xfrm>
         </p:spPr>
         <p:txBody>
           <a:bodyPr/>
-          <a:lstStyle>
-            <a:lvl1pPr>
-              <a:defRPr sz="2800"/>
-            </a:lvl1pPr>
-            <a:lvl2pPr>
-              <a:defRPr sz="2400"/>
-            </a:lvl2pPr>
-            <a:lvl3pPr>
-              <a:defRPr sz="2000"/>
-            </a:lvl3pPr>
-            <a:lvl4pPr>
-              <a:defRPr sz="1800"/>
-            </a:lvl4pPr>
-            <a:lvl5pPr>
-              <a:defRPr sz="1800"/>
-            </a:lvl5pPr>
-            <a:lvl6pPr>
-              <a:defRPr sz="1800"/>
-            </a:lvl6pPr>
-            <a:lvl7pPr>
-              <a:defRPr sz="1800"/>
-            </a:lvl7pPr>
-            <a:lvl8pPr>
-              <a:defRPr sz="1800"/>
-            </a:lvl8pPr>
-            <a:lvl9pPr>
-              <a:defRPr sz="1800"/>
-            </a:lvl9pPr>
-          </a:lstStyle>
+          <a:lstStyle/>
           <a:p>
             <a:pPr lvl="0"/>
             <a:r>
-              <a:rPr lang="en-US" smtClean="0"/>
+              <a:rPr lang="en-US"/>
               <a:t>Click to edit Master text styles</a:t>
             </a:r>
           </a:p>
           <a:p>
             <a:pPr lvl="1"/>
             <a:r>
-              <a:rPr lang="en-US" smtClean="0"/>
+              <a:rPr lang="en-US"/>
               <a:t>Second level</a:t>
             </a:r>
           </a:p>
           <a:p>
             <a:pPr lvl="2"/>
             <a:r>
-              <a:rPr lang="en-US" smtClean="0"/>
+              <a:rPr lang="en-US"/>
               <a:t>Third level</a:t>
             </a:r>
           </a:p>
           <a:p>
             <a:pPr lvl="3"/>
             <a:r>
-              <a:rPr lang="en-US" smtClean="0"/>
+              <a:rPr lang="en-US"/>
               <a:t>Fourth level</a:t>
             </a:r>
           </a:p>
           <a:p>
             <a:pPr lvl="4"/>
             <a:r>
-              <a:rPr lang="en-US" smtClean="0"/>
+              <a:rPr lang="en-US"/>
               <a:t>Fifth level</a:t>
             </a:r>
-            <a:endParaRPr lang="en-US"/>
+            <a:endParaRPr lang="en-US" dirty="0"/>
+          </a:p>
+        </p:txBody>
+      </p:sp>
+      <p:sp>
+        <p:nvSpPr>
+          <p:cNvPr id="4" name="Content Placeholder 3"/>
+          <p:cNvSpPr>
+            <a:spLocks noGrp="1"/>
+          </p:cNvSpPr>
+          <p:nvPr>
+            <p:ph sz="half" idx="2"/>
+          </p:nvPr>
+        </p:nvSpPr>
+        <p:spPr>
+          <a:xfrm>
+            <a:off x="4889182" y="2013936"/>
+            <a:ext cx="3125652" cy="3437559"/>
+          </a:xfrm>
+        </p:spPr>
+        <p:txBody>
+          <a:bodyPr/>
+          <a:lstStyle/>
+          <a:p>
+            <a:pPr lvl="0"/>
+            <a:r>
+              <a:rPr lang="en-US"/>
+              <a:t>Click to edit Master text styles</a:t>
+            </a:r>
+          </a:p>
+          <a:p>
+            <a:pPr lvl="1"/>
+            <a:r>
+              <a:rPr lang="en-US"/>
+              <a:t>Second level</a:t>
+            </a:r>
+          </a:p>
+          <a:p>
+            <a:pPr lvl="2"/>
+            <a:r>
+              <a:rPr lang="en-US"/>
+              <a:t>Third level</a:t>
+            </a:r>
+          </a:p>
+          <a:p>
+            <a:pPr lvl="3"/>
+            <a:r>
+              <a:rPr lang="en-US"/>
+              <a:t>Fourth level</a:t>
+            </a:r>
+          </a:p>
+          <a:p>
+            <a:pPr lvl="4"/>
+            <a:r>
+              <a:rPr lang="en-US"/>
+              <a:t>Fifth level</a:t>
+            </a:r>
+            <a:endParaRPr lang="en-US" dirty="0"/>
           </a:p>
         </p:txBody>
       </p:sp>
@@ -1360,7 +1454,7 @@
           <a:p>
             <a:fld id="{5BCAD085-E8A6-8845-BD4E-CB4CCA059FC4}" type="datetimeFigureOut">
               <a:rPr lang="en-US" smtClean="0"/>
-              <a:t>1/27/13</a:t>
+              <a:t>9/26/25</a:t>
             </a:fld>
             <a:endParaRPr lang="en-US"/>
           </a:p>
@@ -1408,10 +1502,41 @@
           </a:p>
         </p:txBody>
       </p:sp>
+      <p:cxnSp>
+        <p:nvCxnSpPr>
+          <p:cNvPr id="33" name="Straight Connector 32"/>
+          <p:cNvCxnSpPr/>
+          <p:nvPr/>
+        </p:nvCxnSpPr>
+        <p:spPr>
+          <a:xfrm>
+            <a:off x="1443491" y="1847088"/>
+            <a:ext cx="6571343" cy="0"/>
+          </a:xfrm>
+          <a:prstGeom prst="line">
+            <a:avLst/>
+          </a:prstGeom>
+          <a:ln w="31750"/>
+        </p:spPr>
+        <p:style>
+          <a:lnRef idx="3">
+            <a:schemeClr val="accent1"/>
+          </a:lnRef>
+          <a:fillRef idx="0">
+            <a:schemeClr val="accent1"/>
+          </a:fillRef>
+          <a:effectRef idx="2">
+            <a:schemeClr val="accent1"/>
+          </a:effectRef>
+          <a:fontRef idx="minor">
+            <a:schemeClr val="tx1"/>
+          </a:fontRef>
+        </p:style>
+      </p:cxnSp>
     </p:spTree>
     <p:extLst>
       <p:ext uri="{BB962C8B-B14F-4D97-AF65-F5344CB8AC3E}">
-        <p14:creationId xmlns:p14="http://schemas.microsoft.com/office/powerpoint/2010/main" val="2782244947"/>
+        <p14:creationId xmlns:p14="http://schemas.microsoft.com/office/powerpoint/2010/main" val="3807855110"/>
       </p:ext>
     </p:extLst>
   </p:cSld>
@@ -1438,93 +1563,134 @@
           <a:chExt cx="0" cy="0"/>
         </a:xfrm>
       </p:grpSpPr>
-      <p:sp>
-        <p:nvSpPr>
-          <p:cNvPr id="2" name="Title 1"/>
-          <p:cNvSpPr>
-            <a:spLocks noGrp="1"/>
-          </p:cNvSpPr>
-          <p:nvPr>
-            <p:ph type="title"/>
-          </p:nvPr>
-        </p:nvSpPr>
-        <p:spPr/>
-        <p:txBody>
-          <a:bodyPr/>
-          <a:lstStyle>
-            <a:lvl1pPr>
-              <a:defRPr/>
-            </a:lvl1pPr>
-          </a:lstStyle>
-          <a:p>
-            <a:r>
-              <a:rPr lang="en-US" smtClean="0"/>
-              <a:t>Click to edit Master title style</a:t>
-            </a:r>
-            <a:endParaRPr lang="en-US"/>
-          </a:p>
-        </p:txBody>
-      </p:sp>
-      <p:sp>
-        <p:nvSpPr>
-          <p:cNvPr id="3" name="Text Placeholder 2"/>
-          <p:cNvSpPr>
-            <a:spLocks noGrp="1"/>
-          </p:cNvSpPr>
-          <p:nvPr>
-            <p:ph type="body" idx="1"/>
-          </p:nvPr>
-        </p:nvSpPr>
+      <p:cxnSp>
+        <p:nvCxnSpPr>
+          <p:cNvPr id="36" name="Straight Connector 35"/>
+          <p:cNvCxnSpPr/>
+          <p:nvPr/>
+        </p:nvCxnSpPr>
         <p:spPr>
           <a:xfrm>
-            <a:off x="457200" y="1535113"/>
-            <a:ext cx="4040188" cy="639762"/>
+            <a:off x="1443491" y="1847088"/>
+            <a:ext cx="6571343" cy="0"/>
+          </a:xfrm>
+          <a:prstGeom prst="line">
+            <a:avLst/>
+          </a:prstGeom>
+          <a:ln w="31750"/>
+        </p:spPr>
+        <p:style>
+          <a:lnRef idx="3">
+            <a:schemeClr val="accent1"/>
+          </a:lnRef>
+          <a:fillRef idx="0">
+            <a:schemeClr val="accent1"/>
+          </a:fillRef>
+          <a:effectRef idx="2">
+            <a:schemeClr val="accent1"/>
+          </a:effectRef>
+          <a:fontRef idx="minor">
+            <a:schemeClr val="tx1"/>
+          </a:fontRef>
+        </p:style>
+      </p:cxnSp>
+      <p:sp>
+        <p:nvSpPr>
+          <p:cNvPr id="2" name="Title 1"/>
+          <p:cNvSpPr>
+            <a:spLocks noGrp="1"/>
+          </p:cNvSpPr>
+          <p:nvPr>
+            <p:ph type="title"/>
+          </p:nvPr>
+        </p:nvSpPr>
+        <p:spPr>
+          <a:xfrm>
+            <a:off x="1443491" y="804164"/>
+            <a:ext cx="6571344" cy="1056319"/>
           </a:xfrm>
         </p:spPr>
         <p:txBody>
-          <a:bodyPr anchor="b"/>
+          <a:bodyPr/>
+          <a:lstStyle/>
+          <a:p>
+            <a:r>
+              <a:rPr lang="en-US"/>
+              <a:t>Click to edit Master title style</a:t>
+            </a:r>
+            <a:endParaRPr lang="en-US" dirty="0"/>
+          </a:p>
+        </p:txBody>
+      </p:sp>
+      <p:sp>
+        <p:nvSpPr>
+          <p:cNvPr id="3" name="Text Placeholder 2"/>
+          <p:cNvSpPr>
+            <a:spLocks noGrp="1"/>
+          </p:cNvSpPr>
+          <p:nvPr>
+            <p:ph type="body" idx="1"/>
+          </p:nvPr>
+        </p:nvSpPr>
+        <p:spPr>
+          <a:xfrm>
+            <a:off x="1443491" y="2019550"/>
+            <a:ext cx="3125766" cy="801943"/>
+          </a:xfrm>
+        </p:spPr>
+        <p:txBody>
+          <a:bodyPr anchor="b">
+            <a:normAutofit/>
+          </a:bodyPr>
           <a:lstStyle>
             <a:lvl1pPr marL="0" indent="0">
-              <a:buNone/>
-              <a:defRPr sz="2400" b="1"/>
+              <a:lnSpc>
+                <a:spcPct val="100000"/>
+              </a:lnSpc>
+              <a:buNone/>
+              <a:defRPr sz="2200" b="0" cap="all" baseline="0">
+                <a:solidFill>
+                  <a:schemeClr val="accent1"/>
+                </a:solidFill>
+              </a:defRPr>
             </a:lvl1pPr>
-            <a:lvl2pPr marL="457200" indent="0">
-              <a:buNone/>
-              <a:defRPr sz="2000" b="1"/>
+            <a:lvl2pPr marL="342900" indent="0">
+              <a:buNone/>
+              <a:defRPr sz="1500" b="1"/>
             </a:lvl2pPr>
-            <a:lvl3pPr marL="914400" indent="0">
-              <a:buNone/>
-              <a:defRPr sz="1800" b="1"/>
+            <a:lvl3pPr marL="685800" indent="0">
+              <a:buNone/>
+              <a:defRPr sz="1350" b="1"/>
             </a:lvl3pPr>
-            <a:lvl4pPr marL="1371600" indent="0">
-              <a:buNone/>
-              <a:defRPr sz="1600" b="1"/>
+            <a:lvl4pPr marL="1028700" indent="0">
+              <a:buNone/>
+              <a:defRPr sz="1200" b="1"/>
             </a:lvl4pPr>
-            <a:lvl5pPr marL="1828800" indent="0">
-              <a:buNone/>
-              <a:defRPr sz="1600" b="1"/>
+            <a:lvl5pPr marL="1371600" indent="0">
+              <a:buNone/>
+              <a:defRPr sz="1200" b="1"/>
             </a:lvl5pPr>
-            <a:lvl6pPr marL="2286000" indent="0">
-              <a:buNone/>
-              <a:defRPr sz="1600" b="1"/>
+            <a:lvl6pPr marL="1714500" indent="0">
+              <a:buNone/>
+              <a:defRPr sz="1200" b="1"/>
             </a:lvl6pPr>
-            <a:lvl7pPr marL="2743200" indent="0">
-              <a:buNone/>
-              <a:defRPr sz="1600" b="1"/>
+            <a:lvl7pPr marL="2057400" indent="0">
+              <a:buNone/>
+              <a:defRPr sz="1200" b="1"/>
             </a:lvl7pPr>
-            <a:lvl8pPr marL="3200400" indent="0">
-              <a:buNone/>
-              <a:defRPr sz="1600" b="1"/>
+            <a:lvl8pPr marL="2400300" indent="0">
+              <a:buNone/>
+              <a:defRPr sz="1200" b="1"/>
             </a:lvl8pPr>
-            <a:lvl9pPr marL="3657600" indent="0">
-              <a:buNone/>
-              <a:defRPr sz="1600" b="1"/>
+            <a:lvl9pPr marL="2743200" indent="0">
+              <a:buNone/>
+              <a:defRPr sz="1200" b="1"/>
             </a:lvl9pPr>
           </a:lstStyle>
           <a:p>
             <a:pPr lvl="0"/>
             <a:r>
-              <a:rPr lang="en-US" smtClean="0"/>
+              <a:rPr lang="en-US"/>
               <a:t>Click to edit Master text styles</a:t>
             </a:r>
           </a:p>
@@ -1542,226 +1708,179 @@
         </p:nvSpPr>
         <p:spPr>
           <a:xfrm>
-            <a:off x="457200" y="2174875"/>
-            <a:ext cx="4040188" cy="3951288"/>
+            <a:off x="1443491" y="2824270"/>
+            <a:ext cx="3125766" cy="2644457"/>
           </a:xfrm>
         </p:spPr>
         <p:txBody>
           <a:bodyPr/>
+          <a:lstStyle/>
+          <a:p>
+            <a:pPr lvl="0"/>
+            <a:r>
+              <a:rPr lang="en-US"/>
+              <a:t>Click to edit Master text styles</a:t>
+            </a:r>
+          </a:p>
+          <a:p>
+            <a:pPr lvl="1"/>
+            <a:r>
+              <a:rPr lang="en-US"/>
+              <a:t>Second level</a:t>
+            </a:r>
+          </a:p>
+          <a:p>
+            <a:pPr lvl="2"/>
+            <a:r>
+              <a:rPr lang="en-US"/>
+              <a:t>Third level</a:t>
+            </a:r>
+          </a:p>
+          <a:p>
+            <a:pPr lvl="3"/>
+            <a:r>
+              <a:rPr lang="en-US"/>
+              <a:t>Fourth level</a:t>
+            </a:r>
+          </a:p>
+          <a:p>
+            <a:pPr lvl="4"/>
+            <a:r>
+              <a:rPr lang="en-US"/>
+              <a:t>Fifth level</a:t>
+            </a:r>
+            <a:endParaRPr lang="en-US" dirty="0"/>
+          </a:p>
+        </p:txBody>
+      </p:sp>
+      <p:sp>
+        <p:nvSpPr>
+          <p:cNvPr id="5" name="Text Placeholder 4"/>
+          <p:cNvSpPr>
+            <a:spLocks noGrp="1"/>
+          </p:cNvSpPr>
+          <p:nvPr>
+            <p:ph type="body" sz="quarter" idx="3"/>
+          </p:nvPr>
+        </p:nvSpPr>
+        <p:spPr>
+          <a:xfrm>
+            <a:off x="4889182" y="2023004"/>
+            <a:ext cx="3125652" cy="802237"/>
+          </a:xfrm>
+        </p:spPr>
+        <p:txBody>
+          <a:bodyPr anchor="b">
+            <a:normAutofit/>
+          </a:bodyPr>
           <a:lstStyle>
-            <a:lvl1pPr>
-              <a:defRPr sz="2400"/>
+            <a:lvl1pPr marL="0" indent="0">
+              <a:lnSpc>
+                <a:spcPct val="100000"/>
+              </a:lnSpc>
+              <a:buNone/>
+              <a:defRPr sz="2200" b="0" cap="all" baseline="0">
+                <a:solidFill>
+                  <a:schemeClr val="accent1"/>
+                </a:solidFill>
+              </a:defRPr>
             </a:lvl1pPr>
-            <a:lvl2pPr>
-              <a:defRPr sz="2000"/>
+            <a:lvl2pPr marL="342900" indent="0">
+              <a:buNone/>
+              <a:defRPr sz="1500" b="1"/>
             </a:lvl2pPr>
-            <a:lvl3pPr>
-              <a:defRPr sz="1800"/>
+            <a:lvl3pPr marL="685800" indent="0">
+              <a:buNone/>
+              <a:defRPr sz="1350" b="1"/>
             </a:lvl3pPr>
-            <a:lvl4pPr>
-              <a:defRPr sz="1600"/>
+            <a:lvl4pPr marL="1028700" indent="0">
+              <a:buNone/>
+              <a:defRPr sz="1200" b="1"/>
             </a:lvl4pPr>
-            <a:lvl5pPr>
-              <a:defRPr sz="1600"/>
+            <a:lvl5pPr marL="1371600" indent="0">
+              <a:buNone/>
+              <a:defRPr sz="1200" b="1"/>
             </a:lvl5pPr>
-            <a:lvl6pPr>
-              <a:defRPr sz="1600"/>
+            <a:lvl6pPr marL="1714500" indent="0">
+              <a:buNone/>
+              <a:defRPr sz="1200" b="1"/>
             </a:lvl6pPr>
-            <a:lvl7pPr>
-              <a:defRPr sz="1600"/>
+            <a:lvl7pPr marL="2057400" indent="0">
+              <a:buNone/>
+              <a:defRPr sz="1200" b="1"/>
             </a:lvl7pPr>
-            <a:lvl8pPr>
-              <a:defRPr sz="1600"/>
+            <a:lvl8pPr marL="2400300" indent="0">
+              <a:buNone/>
+              <a:defRPr sz="1200" b="1"/>
             </a:lvl8pPr>
-            <a:lvl9pPr>
-              <a:defRPr sz="1600"/>
+            <a:lvl9pPr marL="2743200" indent="0">
+              <a:buNone/>
+              <a:defRPr sz="1200" b="1"/>
             </a:lvl9pPr>
           </a:lstStyle>
           <a:p>
             <a:pPr lvl="0"/>
             <a:r>
-              <a:rPr lang="en-US" smtClean="0"/>
+              <a:rPr lang="en-US"/>
               <a:t>Click to edit Master text styles</a:t>
             </a:r>
           </a:p>
-          <a:p>
-            <a:pPr lvl="1"/>
-            <a:r>
-              <a:rPr lang="en-US" smtClean="0"/>
-              <a:t>Second level</a:t>
-            </a:r>
-          </a:p>
-          <a:p>
-            <a:pPr lvl="2"/>
-            <a:r>
-              <a:rPr lang="en-US" smtClean="0"/>
-              <a:t>Third level</a:t>
-            </a:r>
-          </a:p>
-          <a:p>
-            <a:pPr lvl="3"/>
-            <a:r>
-              <a:rPr lang="en-US" smtClean="0"/>
-              <a:t>Fourth level</a:t>
-            </a:r>
-          </a:p>
-          <a:p>
-            <a:pPr lvl="4"/>
-            <a:r>
-              <a:rPr lang="en-US" smtClean="0"/>
-              <a:t>Fifth level</a:t>
-            </a:r>
-            <a:endParaRPr lang="en-US"/>
-          </a:p>
-        </p:txBody>
-      </p:sp>
-      <p:sp>
-        <p:nvSpPr>
-          <p:cNvPr id="5" name="Text Placeholder 4"/>
-          <p:cNvSpPr>
-            <a:spLocks noGrp="1"/>
-          </p:cNvSpPr>
-          <p:nvPr>
-            <p:ph type="body" sz="quarter" idx="3"/>
+        </p:txBody>
+      </p:sp>
+      <p:sp>
+        <p:nvSpPr>
+          <p:cNvPr id="6" name="Content Placeholder 5"/>
+          <p:cNvSpPr>
+            <a:spLocks noGrp="1"/>
+          </p:cNvSpPr>
+          <p:nvPr>
+            <p:ph sz="quarter" idx="4"/>
           </p:nvPr>
         </p:nvSpPr>
         <p:spPr>
           <a:xfrm>
-            <a:off x="4645025" y="1535113"/>
-            <a:ext cx="4041775" cy="639762"/>
+            <a:off x="4889182" y="2821491"/>
+            <a:ext cx="3125652" cy="2637371"/>
           </a:xfrm>
         </p:spPr>
         <p:txBody>
-          <a:bodyPr anchor="b"/>
-          <a:lstStyle>
-            <a:lvl1pPr marL="0" indent="0">
-              <a:buNone/>
-              <a:defRPr sz="2400" b="1"/>
-            </a:lvl1pPr>
-            <a:lvl2pPr marL="457200" indent="0">
-              <a:buNone/>
-              <a:defRPr sz="2000" b="1"/>
-            </a:lvl2pPr>
-            <a:lvl3pPr marL="914400" indent="0">
-              <a:buNone/>
-              <a:defRPr sz="1800" b="1"/>
-            </a:lvl3pPr>
-            <a:lvl4pPr marL="1371600" indent="0">
-              <a:buNone/>
-              <a:defRPr sz="1600" b="1"/>
-            </a:lvl4pPr>
-            <a:lvl5pPr marL="1828800" indent="0">
-              <a:buNone/>
-              <a:defRPr sz="1600" b="1"/>
-            </a:lvl5pPr>
-            <a:lvl6pPr marL="2286000" indent="0">
-              <a:buNone/>
-              <a:defRPr sz="1600" b="1"/>
-            </a:lvl6pPr>
-            <a:lvl7pPr marL="2743200" indent="0">
-              <a:buNone/>
-              <a:defRPr sz="1600" b="1"/>
-            </a:lvl7pPr>
-            <a:lvl8pPr marL="3200400" indent="0">
-              <a:buNone/>
-              <a:defRPr sz="1600" b="1"/>
-            </a:lvl8pPr>
-            <a:lvl9pPr marL="3657600" indent="0">
-              <a:buNone/>
-              <a:defRPr sz="1600" b="1"/>
-            </a:lvl9pPr>
-          </a:lstStyle>
+          <a:bodyPr/>
+          <a:lstStyle/>
           <a:p>
             <a:pPr lvl="0"/>
             <a:r>
-              <a:rPr lang="en-US" smtClean="0"/>
+              <a:rPr lang="en-US"/>
               <a:t>Click to edit Master text styles</a:t>
             </a:r>
           </a:p>
-        </p:txBody>
-      </p:sp>
-      <p:sp>
-        <p:nvSpPr>
-          <p:cNvPr id="6" name="Content Placeholder 5"/>
-          <p:cNvSpPr>
-            <a:spLocks noGrp="1"/>
-          </p:cNvSpPr>
-          <p:nvPr>
-            <p:ph sz="quarter" idx="4"/>
-          </p:nvPr>
-        </p:nvSpPr>
-        <p:spPr>
-          <a:xfrm>
-            <a:off x="4645025" y="2174875"/>
-            <a:ext cx="4041775" cy="3951288"/>
-          </a:xfrm>
-        </p:spPr>
-        <p:txBody>
-          <a:bodyPr/>
-          <a:lstStyle>
-            <a:lvl1pPr>
-              <a:defRPr sz="2400"/>
-            </a:lvl1pPr>
-            <a:lvl2pPr>
-              <a:defRPr sz="2000"/>
-            </a:lvl2pPr>
-            <a:lvl3pPr>
-              <a:defRPr sz="1800"/>
-            </a:lvl3pPr>
-            <a:lvl4pPr>
-              <a:defRPr sz="1600"/>
-            </a:lvl4pPr>
-            <a:lvl5pPr>
-              <a:defRPr sz="1600"/>
-            </a:lvl5pPr>
-            <a:lvl6pPr>
-              <a:defRPr sz="1600"/>
-            </a:lvl6pPr>
-            <a:lvl7pPr>
-              <a:defRPr sz="1600"/>
-            </a:lvl7pPr>
-            <a:lvl8pPr>
-              <a:defRPr sz="1600"/>
-            </a:lvl8pPr>
-            <a:lvl9pPr>
-              <a:defRPr sz="1600"/>
-            </a:lvl9pPr>
-          </a:lstStyle>
-          <a:p>
-            <a:pPr lvl="0"/>
-            <a:r>
-              <a:rPr lang="en-US" smtClean="0"/>
-              <a:t>Click to edit Master text styles</a:t>
-            </a:r>
-          </a:p>
           <a:p>
             <a:pPr lvl="1"/>
             <a:r>
-              <a:rPr lang="en-US" smtClean="0"/>
+              <a:rPr lang="en-US"/>
               <a:t>Second level</a:t>
             </a:r>
           </a:p>
           <a:p>
             <a:pPr lvl="2"/>
             <a:r>
-              <a:rPr lang="en-US" smtClean="0"/>
+              <a:rPr lang="en-US"/>
               <a:t>Third level</a:t>
             </a:r>
           </a:p>
           <a:p>
             <a:pPr lvl="3"/>
             <a:r>
-              <a:rPr lang="en-US" smtClean="0"/>
+              <a:rPr lang="en-US"/>
               <a:t>Fourth level</a:t>
             </a:r>
           </a:p>
           <a:p>
             <a:pPr lvl="4"/>
             <a:r>
-              <a:rPr lang="en-US" smtClean="0"/>
+              <a:rPr lang="en-US"/>
               <a:t>Fifth level</a:t>
             </a:r>
-            <a:endParaRPr lang="en-US"/>
+            <a:endParaRPr lang="en-US" dirty="0"/>
           </a:p>
         </p:txBody>
       </p:sp>
@@ -1782,7 +1901,7 @@
           <a:p>
             <a:fld id="{5BCAD085-E8A6-8845-BD4E-CB4CCA059FC4}" type="datetimeFigureOut">
               <a:rPr lang="en-US" smtClean="0"/>
-              <a:t>1/27/13</a:t>
+              <a:t>9/26/25</a:t>
             </a:fld>
             <a:endParaRPr lang="en-US"/>
           </a:p>
@@ -1833,7 +1952,7 @@
     </p:spTree>
     <p:extLst>
       <p:ext uri="{BB962C8B-B14F-4D97-AF65-F5344CB8AC3E}">
-        <p14:creationId xmlns:p14="http://schemas.microsoft.com/office/powerpoint/2010/main" val="990158736"/>
+        <p14:creationId xmlns:p14="http://schemas.microsoft.com/office/powerpoint/2010/main" val="1230629328"/>
       </p:ext>
     </p:extLst>
   </p:cSld>
@@ -1860,6 +1979,37 @@
           <a:chExt cx="0" cy="0"/>
         </a:xfrm>
       </p:grpSpPr>
+      <p:cxnSp>
+        <p:nvCxnSpPr>
+          <p:cNvPr id="32" name="Straight Connector 31"/>
+          <p:cNvCxnSpPr/>
+          <p:nvPr/>
+        </p:nvCxnSpPr>
+        <p:spPr>
+          <a:xfrm>
+            <a:off x="1443491" y="1847088"/>
+            <a:ext cx="6571343" cy="0"/>
+          </a:xfrm>
+          <a:prstGeom prst="line">
+            <a:avLst/>
+          </a:prstGeom>
+          <a:ln w="31750"/>
+        </p:spPr>
+        <p:style>
+          <a:lnRef idx="3">
+            <a:schemeClr val="accent1"/>
+          </a:lnRef>
+          <a:fillRef idx="0">
+            <a:schemeClr val="accent1"/>
+          </a:fillRef>
+          <a:effectRef idx="2">
+            <a:schemeClr val="accent1"/>
+          </a:effectRef>
+          <a:fontRef idx="minor">
+            <a:schemeClr val="tx1"/>
+          </a:fontRef>
+        </p:style>
+      </p:cxnSp>
       <p:sp>
         <p:nvSpPr>
           <p:cNvPr id="2" name="Title 1"/>
@@ -1876,10 +2026,10 @@
           <a:lstStyle/>
           <a:p>
             <a:r>
-              <a:rPr lang="en-US" smtClean="0"/>
+              <a:rPr lang="en-US"/>
               <a:t>Click to edit Master title style</a:t>
             </a:r>
-            <a:endParaRPr lang="en-US"/>
+            <a:endParaRPr lang="en-US" dirty="0"/>
           </a:p>
         </p:txBody>
       </p:sp>
@@ -1900,7 +2050,7 @@
           <a:p>
             <a:fld id="{5BCAD085-E8A6-8845-BD4E-CB4CCA059FC4}" type="datetimeFigureOut">
               <a:rPr lang="en-US" smtClean="0"/>
-              <a:t>1/27/13</a:t>
+              <a:t>9/26/25</a:t>
             </a:fld>
             <a:endParaRPr lang="en-US"/>
           </a:p>
@@ -1951,7 +2101,7 @@
     </p:spTree>
     <p:extLst>
       <p:ext uri="{BB962C8B-B14F-4D97-AF65-F5344CB8AC3E}">
-        <p14:creationId xmlns:p14="http://schemas.microsoft.com/office/powerpoint/2010/main" val="727027711"/>
+        <p14:creationId xmlns:p14="http://schemas.microsoft.com/office/powerpoint/2010/main" val="4003458011"/>
       </p:ext>
     </p:extLst>
   </p:cSld>
@@ -1995,7 +2145,7 @@
           <a:p>
             <a:fld id="{5BCAD085-E8A6-8845-BD4E-CB4CCA059FC4}" type="datetimeFigureOut">
               <a:rPr lang="en-US" smtClean="0"/>
-              <a:t>1/27/13</a:t>
+              <a:t>9/26/25</a:t>
             </a:fld>
             <a:endParaRPr lang="en-US"/>
           </a:p>
@@ -2046,7 +2196,7 @@
     </p:spTree>
     <p:extLst>
       <p:ext uri="{BB962C8B-B14F-4D97-AF65-F5344CB8AC3E}">
-        <p14:creationId xmlns:p14="http://schemas.microsoft.com/office/powerpoint/2010/main" val="1212999818"/>
+        <p14:creationId xmlns:p14="http://schemas.microsoft.com/office/powerpoint/2010/main" val="3984036740"/>
       </p:ext>
     </p:extLst>
   </p:cSld>
@@ -2085,23 +2235,25 @@
         </p:nvSpPr>
         <p:spPr>
           <a:xfrm>
-            <a:off x="457200" y="273050"/>
-            <a:ext cx="3008313" cy="1162050"/>
+            <a:off x="1439042" y="798973"/>
+            <a:ext cx="2425950" cy="2247117"/>
           </a:xfrm>
         </p:spPr>
         <p:txBody>
-          <a:bodyPr anchor="b"/>
+          <a:bodyPr anchor="b">
+            <a:normAutofit/>
+          </a:bodyPr>
           <a:lstStyle>
             <a:lvl1pPr algn="l">
-              <a:defRPr sz="2000" b="1"/>
+              <a:defRPr sz="2400"/>
             </a:lvl1pPr>
           </a:lstStyle>
           <a:p>
             <a:r>
-              <a:rPr lang="en-US" smtClean="0"/>
+              <a:rPr lang="en-US"/>
               <a:t>Click to edit Master title style</a:t>
             </a:r>
-            <a:endParaRPr lang="en-US"/>
+            <a:endParaRPr lang="en-US" dirty="0"/>
           </a:p>
         </p:txBody>
       </p:sp>
@@ -2117,139 +2269,113 @@
         </p:nvSpPr>
         <p:spPr>
           <a:xfrm>
-            <a:off x="3575050" y="273050"/>
-            <a:ext cx="5111750" cy="5853113"/>
+            <a:off x="4186656" y="798974"/>
+            <a:ext cx="3828178" cy="4658826"/>
           </a:xfrm>
         </p:spPr>
         <p:txBody>
-          <a:bodyPr/>
+          <a:bodyPr anchor="ctr"/>
+          <a:lstStyle/>
+          <a:p>
+            <a:pPr lvl="0"/>
+            <a:r>
+              <a:rPr lang="en-US"/>
+              <a:t>Click to edit Master text styles</a:t>
+            </a:r>
+          </a:p>
+          <a:p>
+            <a:pPr lvl="1"/>
+            <a:r>
+              <a:rPr lang="en-US"/>
+              <a:t>Second level</a:t>
+            </a:r>
+          </a:p>
+          <a:p>
+            <a:pPr lvl="2"/>
+            <a:r>
+              <a:rPr lang="en-US"/>
+              <a:t>Third level</a:t>
+            </a:r>
+          </a:p>
+          <a:p>
+            <a:pPr lvl="3"/>
+            <a:r>
+              <a:rPr lang="en-US"/>
+              <a:t>Fourth level</a:t>
+            </a:r>
+          </a:p>
+          <a:p>
+            <a:pPr lvl="4"/>
+            <a:r>
+              <a:rPr lang="en-US"/>
+              <a:t>Fifth level</a:t>
+            </a:r>
+            <a:endParaRPr lang="en-US" dirty="0"/>
+          </a:p>
+        </p:txBody>
+      </p:sp>
+      <p:sp>
+        <p:nvSpPr>
+          <p:cNvPr id="4" name="Text Placeholder 3"/>
+          <p:cNvSpPr>
+            <a:spLocks noGrp="1"/>
+          </p:cNvSpPr>
+          <p:nvPr>
+            <p:ph type="body" sz="half" idx="2"/>
+          </p:nvPr>
+        </p:nvSpPr>
+        <p:spPr>
+          <a:xfrm>
+            <a:off x="1439042" y="3205492"/>
+            <a:ext cx="2427369" cy="2248181"/>
+          </a:xfrm>
+        </p:spPr>
+        <p:txBody>
+          <a:bodyPr>
+            <a:normAutofit/>
+          </a:bodyPr>
           <a:lstStyle>
-            <a:lvl1pPr>
-              <a:defRPr sz="3200"/>
+            <a:lvl1pPr marL="0" indent="0" algn="l">
+              <a:buNone/>
+              <a:defRPr sz="1600"/>
             </a:lvl1pPr>
-            <a:lvl2pPr>
-              <a:defRPr sz="2800"/>
+            <a:lvl2pPr marL="342900" indent="0">
+              <a:buNone/>
+              <a:defRPr sz="1050"/>
             </a:lvl2pPr>
-            <a:lvl3pPr>
-              <a:defRPr sz="2400"/>
+            <a:lvl3pPr marL="685800" indent="0">
+              <a:buNone/>
+              <a:defRPr sz="900"/>
             </a:lvl3pPr>
-            <a:lvl4pPr>
-              <a:defRPr sz="2000"/>
+            <a:lvl4pPr marL="1028700" indent="0">
+              <a:buNone/>
+              <a:defRPr sz="750"/>
             </a:lvl4pPr>
-            <a:lvl5pPr>
-              <a:defRPr sz="2000"/>
+            <a:lvl5pPr marL="1371600" indent="0">
+              <a:buNone/>
+              <a:defRPr sz="750"/>
             </a:lvl5pPr>
-            <a:lvl6pPr>
-              <a:defRPr sz="2000"/>
+            <a:lvl6pPr marL="1714500" indent="0">
+              <a:buNone/>
+              <a:defRPr sz="750"/>
             </a:lvl6pPr>
-            <a:lvl7pPr>
-              <a:defRPr sz="2000"/>
+            <a:lvl7pPr marL="2057400" indent="0">
+              <a:buNone/>
+              <a:defRPr sz="750"/>
             </a:lvl7pPr>
-            <a:lvl8pPr>
-              <a:defRPr sz="2000"/>
+            <a:lvl8pPr marL="2400300" indent="0">
+              <a:buNone/>
+              <a:defRPr sz="750"/>
             </a:lvl8pPr>
-            <a:lvl9pPr>
-              <a:defRPr sz="2000"/>
+            <a:lvl9pPr marL="2743200" indent="0">
+              <a:buNone/>
+              <a:defRPr sz="750"/>
             </a:lvl9pPr>
           </a:lstStyle>
           <a:p>
             <a:pPr lvl="0"/>
             <a:r>
-              <a:rPr lang="en-US" smtClean="0"/>
-              <a:t>Click to edit Master text styles</a:t>
-            </a:r>
-          </a:p>
-          <a:p>
-            <a:pPr lvl="1"/>
-            <a:r>
-              <a:rPr lang="en-US" smtClean="0"/>
-              <a:t>Second level</a:t>
-            </a:r>
-          </a:p>
-          <a:p>
-            <a:pPr lvl="2"/>
-            <a:r>
-              <a:rPr lang="en-US" smtClean="0"/>
-              <a:t>Third level</a:t>
-            </a:r>
-          </a:p>
-          <a:p>
-            <a:pPr lvl="3"/>
-            <a:r>
-              <a:rPr lang="en-US" smtClean="0"/>
-              <a:t>Fourth level</a:t>
-            </a:r>
-          </a:p>
-          <a:p>
-            <a:pPr lvl="4"/>
-            <a:r>
-              <a:rPr lang="en-US" smtClean="0"/>
-              <a:t>Fifth level</a:t>
-            </a:r>
-            <a:endParaRPr lang="en-US"/>
-          </a:p>
-        </p:txBody>
-      </p:sp>
-      <p:sp>
-        <p:nvSpPr>
-          <p:cNvPr id="4" name="Text Placeholder 3"/>
-          <p:cNvSpPr>
-            <a:spLocks noGrp="1"/>
-          </p:cNvSpPr>
-          <p:nvPr>
-            <p:ph type="body" sz="half" idx="2"/>
-          </p:nvPr>
-        </p:nvSpPr>
-        <p:spPr>
-          <a:xfrm>
-            <a:off x="457200" y="1435100"/>
-            <a:ext cx="3008313" cy="4691063"/>
-          </a:xfrm>
-        </p:spPr>
-        <p:txBody>
-          <a:bodyPr/>
-          <a:lstStyle>
-            <a:lvl1pPr marL="0" indent="0">
-              <a:buNone/>
-              <a:defRPr sz="1400"/>
-            </a:lvl1pPr>
-            <a:lvl2pPr marL="457200" indent="0">
-              <a:buNone/>
-              <a:defRPr sz="1200"/>
-            </a:lvl2pPr>
-            <a:lvl3pPr marL="914400" indent="0">
-              <a:buNone/>
-              <a:defRPr sz="1000"/>
-            </a:lvl3pPr>
-            <a:lvl4pPr marL="1371600" indent="0">
-              <a:buNone/>
-              <a:defRPr sz="900"/>
-            </a:lvl4pPr>
-            <a:lvl5pPr marL="1828800" indent="0">
-              <a:buNone/>
-              <a:defRPr sz="900"/>
-            </a:lvl5pPr>
-            <a:lvl6pPr marL="2286000" indent="0">
-              <a:buNone/>
-              <a:defRPr sz="900"/>
-            </a:lvl6pPr>
-            <a:lvl7pPr marL="2743200" indent="0">
-              <a:buNone/>
-              <a:defRPr sz="900"/>
-            </a:lvl7pPr>
-            <a:lvl8pPr marL="3200400" indent="0">
-              <a:buNone/>
-              <a:defRPr sz="900"/>
-            </a:lvl8pPr>
-            <a:lvl9pPr marL="3657600" indent="0">
-              <a:buNone/>
-              <a:defRPr sz="900"/>
-            </a:lvl9pPr>
-          </a:lstStyle>
-          <a:p>
-            <a:pPr lvl="0"/>
-            <a:r>
-              <a:rPr lang="en-US" smtClean="0"/>
+              <a:rPr lang="en-US"/>
               <a:t>Click to edit Master text styles</a:t>
             </a:r>
           </a:p>
@@ -2272,7 +2398,7 @@
           <a:p>
             <a:fld id="{5BCAD085-E8A6-8845-BD4E-CB4CCA059FC4}" type="datetimeFigureOut">
               <a:rPr lang="en-US" smtClean="0"/>
-              <a:t>1/27/13</a:t>
+              <a:t>9/26/25</a:t>
             </a:fld>
             <a:endParaRPr lang="en-US"/>
           </a:p>
@@ -2320,10 +2446,41 @@
           </a:p>
         </p:txBody>
       </p:sp>
+      <p:cxnSp>
+        <p:nvCxnSpPr>
+          <p:cNvPr id="17" name="Straight Connector 16"/>
+          <p:cNvCxnSpPr/>
+          <p:nvPr/>
+        </p:nvCxnSpPr>
+        <p:spPr>
+          <a:xfrm>
+            <a:off x="1441748" y="3205491"/>
+            <a:ext cx="2423276" cy="0"/>
+          </a:xfrm>
+          <a:prstGeom prst="line">
+            <a:avLst/>
+          </a:prstGeom>
+          <a:ln w="31750"/>
+        </p:spPr>
+        <p:style>
+          <a:lnRef idx="3">
+            <a:schemeClr val="accent1"/>
+          </a:lnRef>
+          <a:fillRef idx="0">
+            <a:schemeClr val="accent1"/>
+          </a:fillRef>
+          <a:effectRef idx="2">
+            <a:schemeClr val="accent1"/>
+          </a:effectRef>
+          <a:fontRef idx="minor">
+            <a:schemeClr val="tx1"/>
+          </a:fontRef>
+        </p:style>
+      </p:cxnSp>
     </p:spTree>
     <p:extLst>
       <p:ext uri="{BB962C8B-B14F-4D97-AF65-F5344CB8AC3E}">
-        <p14:creationId xmlns:p14="http://schemas.microsoft.com/office/powerpoint/2010/main" val="1840726560"/>
+        <p14:creationId xmlns:p14="http://schemas.microsoft.com/office/powerpoint/2010/main" val="723237671"/>
       </p:ext>
     </p:extLst>
   </p:cSld>
@@ -2350,6 +2507,140 @@
           <a:chExt cx="0" cy="0"/>
         </a:xfrm>
       </p:grpSpPr>
+      <p:grpSp>
+        <p:nvGrpSpPr>
+          <p:cNvPr id="13" name="Group 12"/>
+          <p:cNvGrpSpPr/>
+          <p:nvPr/>
+        </p:nvGrpSpPr>
+        <p:grpSpPr>
+          <a:xfrm>
+            <a:off x="4996501" y="482171"/>
+            <a:ext cx="3511387" cy="5149101"/>
+            <a:chOff x="6852919" y="583365"/>
+            <a:chExt cx="4681849" cy="5181928"/>
+          </a:xfrm>
+        </p:grpSpPr>
+        <p:sp>
+          <p:nvSpPr>
+            <p:cNvPr id="14" name="Rectangle 13"/>
+            <p:cNvSpPr/>
+            <p:nvPr/>
+          </p:nvSpPr>
+          <p:spPr>
+            <a:xfrm>
+              <a:off x="6852919" y="583365"/>
+              <a:ext cx="4681849" cy="5181928"/>
+            </a:xfrm>
+            <a:prstGeom prst="rect">
+              <a:avLst/>
+            </a:prstGeom>
+            <a:gradFill>
+              <a:gsLst>
+                <a:gs pos="0">
+                  <a:srgbClr val="000001"/>
+                </a:gs>
+                <a:gs pos="100000">
+                  <a:srgbClr val="191919"/>
+                </a:gs>
+              </a:gsLst>
+            </a:gradFill>
+            <a:ln w="76200" cmpd="sng">
+              <a:noFill/>
+              <a:miter lim="800000"/>
+            </a:ln>
+            <a:effectLst>
+              <a:outerShdw blurRad="127000" dist="228600" dir="4740000" sx="98000" sy="98000" algn="tl" rotWithShape="0">
+                <a:srgbClr val="000000">
+                  <a:alpha val="34000"/>
+                </a:srgbClr>
+              </a:outerShdw>
+            </a:effectLst>
+            <a:scene3d>
+              <a:camera prst="orthographicFront"/>
+              <a:lightRig rig="threePt" dir="t"/>
+            </a:scene3d>
+            <a:sp3d>
+              <a:bevelT w="152400" h="50800" prst="softRound"/>
+            </a:sp3d>
+          </p:spPr>
+          <p:style>
+            <a:lnRef idx="1">
+              <a:schemeClr val="accent1"/>
+            </a:lnRef>
+            <a:fillRef idx="3">
+              <a:schemeClr val="accent1"/>
+            </a:fillRef>
+            <a:effectRef idx="2">
+              <a:schemeClr val="accent1"/>
+            </a:effectRef>
+            <a:fontRef idx="minor">
+              <a:schemeClr val="lt1"/>
+            </a:fontRef>
+          </p:style>
+        </p:sp>
+        <p:sp>
+          <p:nvSpPr>
+            <p:cNvPr id="15" name="Rectangle 14"/>
+            <p:cNvSpPr/>
+            <p:nvPr/>
+          </p:nvSpPr>
+          <p:spPr>
+            <a:xfrm>
+              <a:off x="7273787" y="915806"/>
+              <a:ext cx="3844017" cy="4507918"/>
+            </a:xfrm>
+            <a:prstGeom prst="rect">
+              <a:avLst/>
+            </a:prstGeom>
+            <a:gradFill>
+              <a:gsLst>
+                <a:gs pos="0">
+                  <a:srgbClr val="DADADA"/>
+                </a:gs>
+                <a:gs pos="100000">
+                  <a:srgbClr val="FFFFFE"/>
+                </a:gs>
+              </a:gsLst>
+              <a:lin ang="16200000" scaled="0"/>
+            </a:gradFill>
+            <a:ln w="50800" cmpd="sng">
+              <a:solidFill>
+                <a:srgbClr val="191919"/>
+              </a:solidFill>
+              <a:miter lim="800000"/>
+            </a:ln>
+            <a:effectLst>
+              <a:innerShdw blurRad="63500" dist="88900" dir="14100000">
+                <a:srgbClr val="000000">
+                  <a:alpha val="30000"/>
+                </a:srgbClr>
+              </a:innerShdw>
+            </a:effectLst>
+            <a:scene3d>
+              <a:camera prst="orthographicFront"/>
+              <a:lightRig rig="threePt" dir="t"/>
+            </a:scene3d>
+            <a:sp3d>
+              <a:bevelT prst="relaxedInset"/>
+            </a:sp3d>
+          </p:spPr>
+          <p:style>
+            <a:lnRef idx="1">
+              <a:schemeClr val="accent1"/>
+            </a:lnRef>
+            <a:fillRef idx="3">
+              <a:schemeClr val="accent1"/>
+            </a:fillRef>
+            <a:effectRef idx="2">
+              <a:schemeClr val="accent1"/>
+            </a:effectRef>
+            <a:fontRef idx="minor">
+              <a:schemeClr val="lt1"/>
+            </a:fontRef>
+          </p:style>
+        </p:sp>
+      </p:grpSp>
       <p:sp>
         <p:nvSpPr>
           <p:cNvPr id="2" name="Title 1"/>
@@ -2362,186 +2653,218 @@
         </p:nvSpPr>
         <p:spPr>
           <a:xfrm>
-            <a:off x="1792288" y="4800600"/>
-            <a:ext cx="5486400" cy="566738"/>
+            <a:off x="1444148" y="1129513"/>
+            <a:ext cx="3244935" cy="1830584"/>
           </a:xfrm>
         </p:spPr>
         <p:txBody>
-          <a:bodyPr anchor="b"/>
+          <a:bodyPr anchor="b">
+            <a:normAutofit/>
+          </a:bodyPr>
+          <a:lstStyle>
+            <a:lvl1pPr>
+              <a:defRPr sz="3200"/>
+            </a:lvl1pPr>
+          </a:lstStyle>
+          <a:p>
+            <a:r>
+              <a:rPr lang="en-US"/>
+              <a:t>Click to edit Master title style</a:t>
+            </a:r>
+            <a:endParaRPr lang="en-US" dirty="0"/>
+          </a:p>
+        </p:txBody>
+      </p:sp>
+      <p:sp>
+        <p:nvSpPr>
+          <p:cNvPr id="3" name="Picture Placeholder 2"/>
+          <p:cNvSpPr>
+            <a:spLocks noGrp="1" noChangeAspect="1"/>
+          </p:cNvSpPr>
+          <p:nvPr>
+            <p:ph type="pic" idx="1"/>
+          </p:nvPr>
+        </p:nvSpPr>
+        <p:spPr>
+          <a:xfrm>
+            <a:off x="5640128" y="1122543"/>
+            <a:ext cx="2234998" cy="3866327"/>
+          </a:xfrm>
+          <a:solidFill>
+            <a:schemeClr val="bg1">
+              <a:lumMod val="85000"/>
+            </a:schemeClr>
+          </a:solidFill>
+          <a:ln w="9525" cap="sq">
+            <a:noFill/>
+            <a:miter lim="800000"/>
+          </a:ln>
+          <a:effectLst/>
+        </p:spPr>
+        <p:txBody>
+          <a:bodyPr anchor="t"/>
+          <a:lstStyle>
+            <a:lvl1pPr marL="0" indent="0" algn="ctr">
+              <a:buNone/>
+              <a:defRPr sz="2400"/>
+            </a:lvl1pPr>
+            <a:lvl2pPr marL="342900" indent="0">
+              <a:buNone/>
+              <a:defRPr sz="2100"/>
+            </a:lvl2pPr>
+            <a:lvl3pPr marL="685800" indent="0">
+              <a:buNone/>
+              <a:defRPr sz="1800"/>
+            </a:lvl3pPr>
+            <a:lvl4pPr marL="1028700" indent="0">
+              <a:buNone/>
+              <a:defRPr sz="1500"/>
+            </a:lvl4pPr>
+            <a:lvl5pPr marL="1371600" indent="0">
+              <a:buNone/>
+              <a:defRPr sz="1500"/>
+            </a:lvl5pPr>
+            <a:lvl6pPr marL="1714500" indent="0">
+              <a:buNone/>
+              <a:defRPr sz="1500"/>
+            </a:lvl6pPr>
+            <a:lvl7pPr marL="2057400" indent="0">
+              <a:buNone/>
+              <a:defRPr sz="1500"/>
+            </a:lvl7pPr>
+            <a:lvl8pPr marL="2400300" indent="0">
+              <a:buNone/>
+              <a:defRPr sz="1500"/>
+            </a:lvl8pPr>
+            <a:lvl9pPr marL="2743200" indent="0">
+              <a:buNone/>
+              <a:defRPr sz="1500"/>
+            </a:lvl9pPr>
+          </a:lstStyle>
+          <a:p>
+            <a:r>
+              <a:rPr lang="en-US"/>
+              <a:t>Click icon to add picture</a:t>
+            </a:r>
+            <a:endParaRPr lang="en-US" dirty="0"/>
+          </a:p>
+        </p:txBody>
+      </p:sp>
+      <p:sp>
+        <p:nvSpPr>
+          <p:cNvPr id="4" name="Text Placeholder 3"/>
+          <p:cNvSpPr>
+            <a:spLocks noGrp="1"/>
+          </p:cNvSpPr>
+          <p:nvPr>
+            <p:ph type="body" sz="half" idx="2"/>
+          </p:nvPr>
+        </p:nvSpPr>
+        <p:spPr>
+          <a:xfrm>
+            <a:off x="1443492" y="3145992"/>
+            <a:ext cx="3240286" cy="2003742"/>
+          </a:xfrm>
+        </p:spPr>
+        <p:txBody>
+          <a:bodyPr>
+            <a:normAutofit/>
+          </a:bodyPr>
+          <a:lstStyle>
+            <a:lvl1pPr marL="0" indent="0" algn="l">
+              <a:buNone/>
+              <a:defRPr sz="1800"/>
+            </a:lvl1pPr>
+            <a:lvl2pPr marL="342900" indent="0">
+              <a:buNone/>
+              <a:defRPr sz="1050"/>
+            </a:lvl2pPr>
+            <a:lvl3pPr marL="685800" indent="0">
+              <a:buNone/>
+              <a:defRPr sz="900"/>
+            </a:lvl3pPr>
+            <a:lvl4pPr marL="1028700" indent="0">
+              <a:buNone/>
+              <a:defRPr sz="750"/>
+            </a:lvl4pPr>
+            <a:lvl5pPr marL="1371600" indent="0">
+              <a:buNone/>
+              <a:defRPr sz="750"/>
+            </a:lvl5pPr>
+            <a:lvl6pPr marL="1714500" indent="0">
+              <a:buNone/>
+              <a:defRPr sz="750"/>
+            </a:lvl6pPr>
+            <a:lvl7pPr marL="2057400" indent="0">
+              <a:buNone/>
+              <a:defRPr sz="750"/>
+            </a:lvl7pPr>
+            <a:lvl8pPr marL="2400300" indent="0">
+              <a:buNone/>
+              <a:defRPr sz="750"/>
+            </a:lvl8pPr>
+            <a:lvl9pPr marL="2743200" indent="0">
+              <a:buNone/>
+              <a:defRPr sz="750"/>
+            </a:lvl9pPr>
+          </a:lstStyle>
+          <a:p>
+            <a:pPr lvl="0"/>
+            <a:r>
+              <a:rPr lang="en-US"/>
+              <a:t>Click to edit Master text styles</a:t>
+            </a:r>
+          </a:p>
+        </p:txBody>
+      </p:sp>
+      <p:sp>
+        <p:nvSpPr>
+          <p:cNvPr id="5" name="Date Placeholder 4"/>
+          <p:cNvSpPr>
+            <a:spLocks noGrp="1"/>
+          </p:cNvSpPr>
+          <p:nvPr>
+            <p:ph type="dt" sz="half" idx="10"/>
+          </p:nvPr>
+        </p:nvSpPr>
+        <p:spPr>
+          <a:xfrm>
+            <a:off x="1436664" y="5469857"/>
+            <a:ext cx="3252420" cy="320123"/>
+          </a:xfrm>
+        </p:spPr>
+        <p:txBody>
+          <a:bodyPr/>
           <a:lstStyle>
             <a:lvl1pPr algn="l">
-              <a:defRPr sz="2000" b="1"/>
+              <a:defRPr/>
             </a:lvl1pPr>
           </a:lstStyle>
           <a:p>
-            <a:r>
+            <a:fld id="{5BCAD085-E8A6-8845-BD4E-CB4CCA059FC4}" type="datetimeFigureOut">
               <a:rPr lang="en-US" smtClean="0"/>
-              <a:t>Click to edit Master title style</a:t>
-            </a:r>
+              <a:t>9/26/25</a:t>
+            </a:fld>
             <a:endParaRPr lang="en-US"/>
           </a:p>
         </p:txBody>
       </p:sp>
       <p:sp>
         <p:nvSpPr>
-          <p:cNvPr id="3" name="Picture Placeholder 2"/>
-          <p:cNvSpPr>
-            <a:spLocks noGrp="1"/>
-          </p:cNvSpPr>
-          <p:nvPr>
-            <p:ph type="pic" idx="1"/>
+          <p:cNvPr id="6" name="Footer Placeholder 5"/>
+          <p:cNvSpPr>
+            <a:spLocks noGrp="1"/>
+          </p:cNvSpPr>
+          <p:nvPr>
+            <p:ph type="ftr" sz="quarter" idx="11"/>
           </p:nvPr>
         </p:nvSpPr>
         <p:spPr>
           <a:xfrm>
-            <a:off x="1792288" y="612775"/>
-            <a:ext cx="5486400" cy="4114800"/>
+            <a:off x="1437530" y="318641"/>
+            <a:ext cx="3251553" cy="320931"/>
           </a:xfrm>
         </p:spPr>
-        <p:txBody>
-          <a:bodyPr/>
-          <a:lstStyle>
-            <a:lvl1pPr marL="0" indent="0">
-              <a:buNone/>
-              <a:defRPr sz="3200"/>
-            </a:lvl1pPr>
-            <a:lvl2pPr marL="457200" indent="0">
-              <a:buNone/>
-              <a:defRPr sz="2800"/>
-            </a:lvl2pPr>
-            <a:lvl3pPr marL="914400" indent="0">
-              <a:buNone/>
-              <a:defRPr sz="2400"/>
-            </a:lvl3pPr>
-            <a:lvl4pPr marL="1371600" indent="0">
-              <a:buNone/>
-              <a:defRPr sz="2000"/>
-            </a:lvl4pPr>
-            <a:lvl5pPr marL="1828800" indent="0">
-              <a:buNone/>
-              <a:defRPr sz="2000"/>
-            </a:lvl5pPr>
-            <a:lvl6pPr marL="2286000" indent="0">
-              <a:buNone/>
-              <a:defRPr sz="2000"/>
-            </a:lvl6pPr>
-            <a:lvl7pPr marL="2743200" indent="0">
-              <a:buNone/>
-              <a:defRPr sz="2000"/>
-            </a:lvl7pPr>
-            <a:lvl8pPr marL="3200400" indent="0">
-              <a:buNone/>
-              <a:defRPr sz="2000"/>
-            </a:lvl8pPr>
-            <a:lvl9pPr marL="3657600" indent="0">
-              <a:buNone/>
-              <a:defRPr sz="2000"/>
-            </a:lvl9pPr>
-          </a:lstStyle>
-          <a:p>
-            <a:endParaRPr lang="en-US"/>
-          </a:p>
-        </p:txBody>
-      </p:sp>
-      <p:sp>
-        <p:nvSpPr>
-          <p:cNvPr id="4" name="Text Placeholder 3"/>
-          <p:cNvSpPr>
-            <a:spLocks noGrp="1"/>
-          </p:cNvSpPr>
-          <p:nvPr>
-            <p:ph type="body" sz="half" idx="2"/>
-          </p:nvPr>
-        </p:nvSpPr>
-        <p:spPr>
-          <a:xfrm>
-            <a:off x="1792288" y="5367338"/>
-            <a:ext cx="5486400" cy="804862"/>
-          </a:xfrm>
-        </p:spPr>
-        <p:txBody>
-          <a:bodyPr/>
-          <a:lstStyle>
-            <a:lvl1pPr marL="0" indent="0">
-              <a:buNone/>
-              <a:defRPr sz="1400"/>
-            </a:lvl1pPr>
-            <a:lvl2pPr marL="457200" indent="0">
-              <a:buNone/>
-              <a:defRPr sz="1200"/>
-            </a:lvl2pPr>
-            <a:lvl3pPr marL="914400" indent="0">
-              <a:buNone/>
-              <a:defRPr sz="1000"/>
-            </a:lvl3pPr>
-            <a:lvl4pPr marL="1371600" indent="0">
-              <a:buNone/>
-              <a:defRPr sz="900"/>
-            </a:lvl4pPr>
-            <a:lvl5pPr marL="1828800" indent="0">
-              <a:buNone/>
-              <a:defRPr sz="900"/>
-            </a:lvl5pPr>
-            <a:lvl6pPr marL="2286000" indent="0">
-              <a:buNone/>
-              <a:defRPr sz="900"/>
-            </a:lvl6pPr>
-            <a:lvl7pPr marL="2743200" indent="0">
-              <a:buNone/>
-              <a:defRPr sz="900"/>
-            </a:lvl7pPr>
-            <a:lvl8pPr marL="3200400" indent="0">
-              <a:buNone/>
-              <a:defRPr sz="900"/>
-            </a:lvl8pPr>
-            <a:lvl9pPr marL="3657600" indent="0">
-              <a:buNone/>
-              <a:defRPr sz="900"/>
-            </a:lvl9pPr>
-          </a:lstStyle>
-          <a:p>
-            <a:pPr lvl="0"/>
-            <a:r>
-              <a:rPr lang="en-US" smtClean="0"/>
-              <a:t>Click to edit Master text styles</a:t>
-            </a:r>
-          </a:p>
-        </p:txBody>
-      </p:sp>
-      <p:sp>
-        <p:nvSpPr>
-          <p:cNvPr id="5" name="Date Placeholder 4"/>
-          <p:cNvSpPr>
-            <a:spLocks noGrp="1"/>
-          </p:cNvSpPr>
-          <p:nvPr>
-            <p:ph type="dt" sz="half" idx="10"/>
-          </p:nvPr>
-        </p:nvSpPr>
-        <p:spPr/>
-        <p:txBody>
-          <a:bodyPr/>
-          <a:lstStyle/>
-          <a:p>
-            <a:fld id="{5BCAD085-E8A6-8845-BD4E-CB4CCA059FC4}" type="datetimeFigureOut">
-              <a:rPr lang="en-US" smtClean="0"/>
-              <a:t>1/27/13</a:t>
-            </a:fld>
-            <a:endParaRPr lang="en-US"/>
-          </a:p>
-        </p:txBody>
-      </p:sp>
-      <p:sp>
-        <p:nvSpPr>
-          <p:cNvPr id="6" name="Footer Placeholder 5"/>
-          <p:cNvSpPr>
-            <a:spLocks noGrp="1"/>
-          </p:cNvSpPr>
-          <p:nvPr>
-            <p:ph type="ftr" sz="quarter" idx="11"/>
-          </p:nvPr>
-        </p:nvSpPr>
-        <p:spPr/>
         <p:txBody>
           <a:bodyPr/>
           <a:lstStyle/>
@@ -2573,10 +2896,41 @@
           </a:p>
         </p:txBody>
       </p:sp>
+      <p:cxnSp>
+        <p:nvCxnSpPr>
+          <p:cNvPr id="31" name="Straight Connector 30"/>
+          <p:cNvCxnSpPr/>
+          <p:nvPr/>
+        </p:nvCxnSpPr>
+        <p:spPr>
+          <a:xfrm>
+            <a:off x="1441281" y="3143605"/>
+            <a:ext cx="3242014" cy="0"/>
+          </a:xfrm>
+          <a:prstGeom prst="line">
+            <a:avLst/>
+          </a:prstGeom>
+          <a:ln w="31750"/>
+        </p:spPr>
+        <p:style>
+          <a:lnRef idx="3">
+            <a:schemeClr val="accent1"/>
+          </a:lnRef>
+          <a:fillRef idx="0">
+            <a:schemeClr val="accent1"/>
+          </a:fillRef>
+          <a:effectRef idx="2">
+            <a:schemeClr val="accent1"/>
+          </a:effectRef>
+          <a:fontRef idx="minor">
+            <a:schemeClr val="tx1"/>
+          </a:fontRef>
+        </p:style>
+      </p:cxnSp>
     </p:spTree>
     <p:extLst>
       <p:ext uri="{BB962C8B-B14F-4D97-AF65-F5344CB8AC3E}">
-        <p14:creationId xmlns:p14="http://schemas.microsoft.com/office/powerpoint/2010/main" val="3889236939"/>
+        <p14:creationId xmlns:p14="http://schemas.microsoft.com/office/powerpoint/2010/main" val="1001630080"/>
       </p:ext>
     </p:extLst>
   </p:cSld>
@@ -2590,8 +2944,8 @@
 <p:sldMaster xmlns:a="http://schemas.openxmlformats.org/drawingml/2006/main" xmlns:r="http://schemas.openxmlformats.org/officeDocument/2006/relationships" xmlns:p="http://schemas.openxmlformats.org/presentationml/2006/main">
   <p:cSld>
     <p:bg>
-      <p:bgRef idx="1001">
-        <a:schemeClr val="bg1"/>
+      <p:bgRef idx="1003">
+        <a:schemeClr val="bg2"/>
       </p:bgRef>
     </p:bg>
     <p:spTree>
@@ -2610,123 +2964,238 @@
       </p:grpSpPr>
       <p:sp>
         <p:nvSpPr>
-          <p:cNvPr id="2" name="Title Placeholder 1"/>
-          <p:cNvSpPr>
-            <a:spLocks noGrp="1"/>
-          </p:cNvSpPr>
-          <p:nvPr>
-            <p:ph type="title"/>
-          </p:nvPr>
+          <p:cNvPr id="10" name="Rectangle 9"/>
+          <p:cNvSpPr/>
+          <p:nvPr/>
         </p:nvSpPr>
         <p:spPr>
           <a:xfrm>
-            <a:off x="457200" y="274638"/>
-            <a:ext cx="8229600" cy="1143000"/>
+            <a:off x="0" y="2015734"/>
+            <a:ext cx="9144000" cy="4079520"/>
+          </a:xfrm>
+          <a:prstGeom prst="rect">
+            <a:avLst/>
+          </a:prstGeom>
+          <a:gradFill flip="none" rotWithShape="1">
+            <a:gsLst>
+              <a:gs pos="0">
+                <a:schemeClr val="bg2">
+                  <a:alpha val="0"/>
+                </a:schemeClr>
+              </a:gs>
+              <a:gs pos="100000">
+                <a:schemeClr val="bg2"/>
+              </a:gs>
+            </a:gsLst>
+            <a:lin ang="5400000" scaled="0"/>
+            <a:tileRect/>
+          </a:gradFill>
+          <a:ln>
+            <a:noFill/>
+          </a:ln>
+        </p:spPr>
+        <p:style>
+          <a:lnRef idx="2">
+            <a:schemeClr val="accent1">
+              <a:shade val="50000"/>
+            </a:schemeClr>
+          </a:lnRef>
+          <a:fillRef idx="1">
+            <a:schemeClr val="accent1"/>
+          </a:fillRef>
+          <a:effectRef idx="0">
+            <a:schemeClr val="accent1"/>
+          </a:effectRef>
+          <a:fontRef idx="minor">
+            <a:schemeClr val="lt1"/>
+          </a:fontRef>
+        </p:style>
+      </p:sp>
+      <p:pic>
+        <p:nvPicPr>
+          <p:cNvPr id="12" name="Picture 11"/>
+          <p:cNvPicPr>
+            <a:picLocks noChangeAspect="1"/>
+          </p:cNvPicPr>
+          <p:nvPr/>
+        </p:nvPicPr>
+        <p:blipFill rotWithShape="1">
+          <a:blip r:embed="rId13">
+            <a:extLst>
+              <a:ext uri="{28A0092B-C50C-407E-A947-70E740481C1C}">
+                <a14:useLocalDpi xmlns:a14="http://schemas.microsoft.com/office/drawing/2010/main" val="0"/>
+              </a:ext>
+            </a:extLst>
+          </a:blip>
+          <a:srcRect l="12500" t="1538" r="12500" b="-1538"/>
+          <a:stretch/>
+        </p:blipFill>
+        <p:spPr>
+          <a:xfrm>
+            <a:off x="-1" y="6095253"/>
+            <a:ext cx="9144001" cy="774727"/>
           </a:xfrm>
           <a:prstGeom prst="rect">
             <a:avLst/>
           </a:prstGeom>
         </p:spPr>
-        <p:txBody>
-          <a:bodyPr vert="horz" lIns="91440" tIns="45720" rIns="91440" bIns="45720" rtlCol="0" anchor="ctr">
-            <a:normAutofit/>
-          </a:bodyPr>
-          <a:lstStyle/>
-          <a:p>
-            <a:r>
-              <a:rPr lang="en-US" smtClean="0"/>
-              <a:t>Click to edit Master title style</a:t>
-            </a:r>
-            <a:endParaRPr lang="en-US"/>
-          </a:p>
-        </p:txBody>
-      </p:sp>
-      <p:sp>
-        <p:nvSpPr>
-          <p:cNvPr id="3" name="Text Placeholder 2"/>
-          <p:cNvSpPr>
-            <a:spLocks noGrp="1"/>
-          </p:cNvSpPr>
-          <p:nvPr>
-            <p:ph type="body" idx="1"/>
-          </p:nvPr>
-        </p:nvSpPr>
+      </p:pic>
+      <p:cxnSp>
+        <p:nvCxnSpPr>
+          <p:cNvPr id="13" name="Straight Connector 12"/>
+          <p:cNvCxnSpPr/>
+          <p:nvPr/>
+        </p:nvCxnSpPr>
         <p:spPr>
           <a:xfrm>
-            <a:off x="457200" y="1600200"/>
-            <a:ext cx="8229600" cy="4525963"/>
+            <a:off x="0" y="6101127"/>
+            <a:ext cx="9144000" cy="0"/>
+          </a:xfrm>
+          <a:prstGeom prst="line">
+            <a:avLst/>
+          </a:prstGeom>
+          <a:ln w="12700">
+            <a:solidFill>
+              <a:srgbClr val="000001">
+                <a:alpha val="20000"/>
+              </a:srgbClr>
+            </a:solidFill>
+          </a:ln>
+        </p:spPr>
+        <p:style>
+          <a:lnRef idx="1">
+            <a:schemeClr val="accent1"/>
+          </a:lnRef>
+          <a:fillRef idx="0">
+            <a:schemeClr val="accent1"/>
+          </a:fillRef>
+          <a:effectRef idx="0">
+            <a:schemeClr val="accent1"/>
+          </a:effectRef>
+          <a:fontRef idx="minor">
+            <a:schemeClr val="tx1"/>
+          </a:fontRef>
+        </p:style>
+      </p:cxnSp>
+      <p:sp>
+        <p:nvSpPr>
+          <p:cNvPr id="2" name="Title Placeholder 1"/>
+          <p:cNvSpPr>
+            <a:spLocks noGrp="1"/>
+          </p:cNvSpPr>
+          <p:nvPr>
+            <p:ph type="title"/>
+          </p:nvPr>
+        </p:nvSpPr>
+        <p:spPr>
+          <a:xfrm>
+            <a:off x="1443491" y="804520"/>
+            <a:ext cx="6571343" cy="1049235"/>
           </a:xfrm>
           <a:prstGeom prst="rect">
             <a:avLst/>
           </a:prstGeom>
         </p:spPr>
         <p:txBody>
-          <a:bodyPr vert="horz" lIns="91440" tIns="45720" rIns="91440" bIns="45720" rtlCol="0">
+          <a:bodyPr vert="horz" lIns="91440" tIns="45720" rIns="91440" bIns="45720" rtlCol="0" anchor="t">
             <a:normAutofit/>
           </a:bodyPr>
           <a:lstStyle/>
           <a:p>
-            <a:pPr lvl="0"/>
-            <a:r>
-              <a:rPr lang="en-US" smtClean="0"/>
-              <a:t>Click to edit Master text styles</a:t>
-            </a:r>
-          </a:p>
-          <a:p>
-            <a:pPr lvl="1"/>
-            <a:r>
-              <a:rPr lang="en-US" smtClean="0"/>
-              <a:t>Second level</a:t>
-            </a:r>
-          </a:p>
-          <a:p>
-            <a:pPr lvl="2"/>
-            <a:r>
-              <a:rPr lang="en-US" smtClean="0"/>
-              <a:t>Third level</a:t>
-            </a:r>
-          </a:p>
-          <a:p>
-            <a:pPr lvl="3"/>
-            <a:r>
-              <a:rPr lang="en-US" smtClean="0"/>
-              <a:t>Fourth level</a:t>
-            </a:r>
-          </a:p>
-          <a:p>
-            <a:pPr lvl="4"/>
-            <a:r>
-              <a:rPr lang="en-US" smtClean="0"/>
-              <a:t>Fifth level</a:t>
-            </a:r>
-            <a:endParaRPr lang="en-US"/>
-          </a:p>
-        </p:txBody>
-      </p:sp>
-      <p:sp>
-        <p:nvSpPr>
-          <p:cNvPr id="4" name="Date Placeholder 3"/>
-          <p:cNvSpPr>
-            <a:spLocks noGrp="1"/>
-          </p:cNvSpPr>
-          <p:nvPr>
-            <p:ph type="dt" sz="half" idx="2"/>
+            <a:r>
+              <a:rPr lang="en-US"/>
+              <a:t>Click to edit Master title style</a:t>
+            </a:r>
+            <a:endParaRPr lang="en-US" dirty="0"/>
+          </a:p>
+        </p:txBody>
+      </p:sp>
+      <p:sp>
+        <p:nvSpPr>
+          <p:cNvPr id="3" name="Text Placeholder 2"/>
+          <p:cNvSpPr>
+            <a:spLocks noGrp="1"/>
+          </p:cNvSpPr>
+          <p:nvPr>
+            <p:ph type="body" idx="1"/>
           </p:nvPr>
         </p:nvSpPr>
         <p:spPr>
           <a:xfrm>
-            <a:off x="457200" y="6356350"/>
-            <a:ext cx="2133600" cy="365125"/>
+            <a:off x="1443491" y="2015733"/>
+            <a:ext cx="6571343" cy="3450613"/>
           </a:xfrm>
           <a:prstGeom prst="rect">
             <a:avLst/>
           </a:prstGeom>
         </p:spPr>
         <p:txBody>
+          <a:bodyPr vert="horz" lIns="91440" tIns="45720" rIns="91440" bIns="45720" rtlCol="0">
+            <a:normAutofit/>
+          </a:bodyPr>
+          <a:lstStyle/>
+          <a:p>
+            <a:pPr lvl="0"/>
+            <a:r>
+              <a:rPr lang="en-US"/>
+              <a:t>Click to edit Master text styles</a:t>
+            </a:r>
+          </a:p>
+          <a:p>
+            <a:pPr lvl="1"/>
+            <a:r>
+              <a:rPr lang="en-US"/>
+              <a:t>Second level</a:t>
+            </a:r>
+          </a:p>
+          <a:p>
+            <a:pPr lvl="2"/>
+            <a:r>
+              <a:rPr lang="en-US"/>
+              <a:t>Third level</a:t>
+            </a:r>
+          </a:p>
+          <a:p>
+            <a:pPr lvl="3"/>
+            <a:r>
+              <a:rPr lang="en-US"/>
+              <a:t>Fourth level</a:t>
+            </a:r>
+          </a:p>
+          <a:p>
+            <a:pPr lvl="4"/>
+            <a:r>
+              <a:rPr lang="en-US"/>
+              <a:t>Fifth level</a:t>
+            </a:r>
+            <a:endParaRPr lang="en-US" dirty="0"/>
+          </a:p>
+        </p:txBody>
+      </p:sp>
+      <p:sp>
+        <p:nvSpPr>
+          <p:cNvPr id="4" name="Date Placeholder 3"/>
+          <p:cNvSpPr>
+            <a:spLocks noGrp="1"/>
+          </p:cNvSpPr>
+          <p:nvPr>
+            <p:ph type="dt" sz="half" idx="2"/>
+          </p:nvPr>
+        </p:nvSpPr>
+        <p:spPr>
+          <a:xfrm>
+            <a:off x="5646542" y="330370"/>
+            <a:ext cx="2368292" cy="309201"/>
+          </a:xfrm>
+          <a:prstGeom prst="rect">
+            <a:avLst/>
+          </a:prstGeom>
+        </p:spPr>
+        <p:txBody>
           <a:bodyPr vert="horz" lIns="91440" tIns="45720" rIns="91440" bIns="45720" rtlCol="0" anchor="ctr"/>
           <a:lstStyle>
-            <a:lvl1pPr algn="l">
-              <a:defRPr sz="1200">
+            <a:lvl1pPr algn="r">
+              <a:defRPr sz="1000">
                 <a:solidFill>
                   <a:schemeClr val="tx1">
                     <a:tint val="75000"/>
@@ -2738,7 +3207,7 @@
           <a:p>
             <a:fld id="{5BCAD085-E8A6-8845-BD4E-CB4CCA059FC4}" type="datetimeFigureOut">
               <a:rPr lang="en-US" smtClean="0"/>
-              <a:t>1/27/13</a:t>
+              <a:t>9/26/25</a:t>
             </a:fld>
             <a:endParaRPr lang="en-US"/>
           </a:p>
@@ -2756,8 +3225,8 @@
         </p:nvSpPr>
         <p:spPr>
           <a:xfrm>
-            <a:off x="3124200" y="6356350"/>
-            <a:ext cx="2895600" cy="365125"/>
+            <a:off x="1443491" y="329308"/>
+            <a:ext cx="4034004" cy="309201"/>
           </a:xfrm>
           <a:prstGeom prst="rect">
             <a:avLst/>
@@ -2766,8 +3235,8 @@
         <p:txBody>
           <a:bodyPr vert="horz" lIns="91440" tIns="45720" rIns="91440" bIns="45720" rtlCol="0" anchor="ctr"/>
           <a:lstStyle>
-            <a:lvl1pPr algn="ctr">
-              <a:defRPr sz="1200">
+            <a:lvl1pPr algn="l">
+              <a:defRPr sz="1000">
                 <a:solidFill>
                   <a:schemeClr val="tx1">
                     <a:tint val="75000"/>
@@ -2793,22 +3262,20 @@
         </p:nvSpPr>
         <p:spPr>
           <a:xfrm>
-            <a:off x="6553200" y="6356350"/>
-            <a:ext cx="2133600" cy="365125"/>
+            <a:off x="487725" y="798973"/>
+            <a:ext cx="795746" cy="503578"/>
           </a:xfrm>
           <a:prstGeom prst="rect">
             <a:avLst/>
           </a:prstGeom>
         </p:spPr>
         <p:txBody>
-          <a:bodyPr vert="horz" lIns="91440" tIns="45720" rIns="91440" bIns="45720" rtlCol="0" anchor="ctr"/>
+          <a:bodyPr vert="horz" lIns="91440" tIns="45720" rIns="91440" bIns="45720" rtlCol="0" anchor="t"/>
           <a:lstStyle>
             <a:lvl1pPr algn="r">
-              <a:defRPr sz="1200">
+              <a:defRPr sz="2800">
                 <a:solidFill>
-                  <a:schemeClr val="tx1">
-                    <a:tint val="75000"/>
-                  </a:schemeClr>
+                  <a:schemeClr val="accent1"/>
                 </a:solidFill>
               </a:defRPr>
             </a:lvl1pPr>
@@ -2825,35 +3292,39 @@
     </p:spTree>
     <p:extLst>
       <p:ext uri="{BB962C8B-B14F-4D97-AF65-F5344CB8AC3E}">
-        <p14:creationId xmlns:p14="http://schemas.microsoft.com/office/powerpoint/2010/main" val="2209977519"/>
+        <p14:creationId xmlns:p14="http://schemas.microsoft.com/office/powerpoint/2010/main" val="967807828"/>
       </p:ext>
     </p:extLst>
   </p:cSld>
   <p:clrMap bg1="lt1" tx1="dk1" bg2="lt2" tx2="dk2" accent1="accent1" accent2="accent2" accent3="accent3" accent4="accent4" accent5="accent5" accent6="accent6" hlink="hlink" folHlink="folHlink"/>
   <p:sldLayoutIdLst>
-    <p:sldLayoutId id="2147483649" r:id="rId1"/>
-    <p:sldLayoutId id="2147483650" r:id="rId2"/>
-    <p:sldLayoutId id="2147483651" r:id="rId3"/>
-    <p:sldLayoutId id="2147483652" r:id="rId4"/>
-    <p:sldLayoutId id="2147483653" r:id="rId5"/>
-    <p:sldLayoutId id="2147483654" r:id="rId6"/>
-    <p:sldLayoutId id="2147483655" r:id="rId7"/>
-    <p:sldLayoutId id="2147483656" r:id="rId8"/>
-    <p:sldLayoutId id="2147483657" r:id="rId9"/>
-    <p:sldLayoutId id="2147483658" r:id="rId10"/>
-    <p:sldLayoutId id="2147483659" r:id="rId11"/>
+    <p:sldLayoutId id="2147483745" r:id="rId1"/>
+    <p:sldLayoutId id="2147483746" r:id="rId2"/>
+    <p:sldLayoutId id="2147483747" r:id="rId3"/>
+    <p:sldLayoutId id="2147483748" r:id="rId4"/>
+    <p:sldLayoutId id="2147483749" r:id="rId5"/>
+    <p:sldLayoutId id="2147483750" r:id="rId6"/>
+    <p:sldLayoutId id="2147483751" r:id="rId7"/>
+    <p:sldLayoutId id="2147483752" r:id="rId8"/>
+    <p:sldLayoutId id="2147483753" r:id="rId9"/>
+    <p:sldLayoutId id="2147483754" r:id="rId10"/>
+    <p:sldLayoutId id="2147483755" r:id="rId11"/>
   </p:sldLayoutIdLst>
   <p:txStyles>
     <p:titleStyle>
-      <a:lvl1pPr algn="ctr" defTabSz="457200" rtl="0" eaLnBrk="1" latinLnBrk="0" hangingPunct="1">
+      <a:lvl1pPr algn="l" defTabSz="685800" rtl="0" eaLnBrk="1" latinLnBrk="0" hangingPunct="1">
+        <a:lnSpc>
+          <a:spcPct val="90000"/>
+        </a:lnSpc>
         <a:spcBef>
           <a:spcPct val="0"/>
         </a:spcBef>
         <a:buNone/>
-        <a:defRPr sz="4400" kern="1200">
+        <a:defRPr sz="3200" b="0" i="0" kern="1200" cap="all">
           <a:solidFill>
             <a:schemeClr val="tx1"/>
           </a:solidFill>
+          <a:effectLst/>
           <a:latin typeface="+mj-lt"/>
           <a:ea typeface="+mj-ea"/>
           <a:cs typeface="+mj-cs"/>
@@ -2861,136 +3332,208 @@
       </a:lvl1pPr>
     </p:titleStyle>
     <p:bodyStyle>
-      <a:lvl1pPr marL="342900" indent="-342900" algn="l" defTabSz="457200" rtl="0" eaLnBrk="1" latinLnBrk="0" hangingPunct="1">
+      <a:lvl1pPr marL="228600" indent="-228600" algn="l" defTabSz="685800" rtl="0" eaLnBrk="1" latinLnBrk="0" hangingPunct="1">
+        <a:lnSpc>
+          <a:spcPct val="120000"/>
+        </a:lnSpc>
         <a:spcBef>
-          <a:spcPct val="20000"/>
+          <a:spcPts val="1000"/>
         </a:spcBef>
-        <a:buFont typeface="Arial"/>
+        <a:buClr>
+          <a:schemeClr val="accent1"/>
+        </a:buClr>
+        <a:buSzPct val="100000"/>
+        <a:buFont typeface="Arial" panose="020B0604020202020204" pitchFamily="34" charset="0"/>
         <a:buChar char="•"/>
-        <a:defRPr sz="3200" kern="1200">
+        <a:defRPr sz="2000" kern="1200" cap="none">
           <a:solidFill>
             <a:schemeClr val="tx1"/>
           </a:solidFill>
+          <a:effectLst/>
           <a:latin typeface="+mn-lt"/>
           <a:ea typeface="+mn-ea"/>
           <a:cs typeface="+mn-cs"/>
         </a:defRPr>
       </a:lvl1pPr>
-      <a:lvl2pPr marL="742950" indent="-285750" algn="l" defTabSz="457200" rtl="0" eaLnBrk="1" latinLnBrk="0" hangingPunct="1">
+      <a:lvl2pPr marL="685800" indent="-228600" algn="l" defTabSz="685800" rtl="0" eaLnBrk="1" latinLnBrk="0" hangingPunct="1">
+        <a:lnSpc>
+          <a:spcPct val="120000"/>
+        </a:lnSpc>
         <a:spcBef>
-          <a:spcPct val="20000"/>
+          <a:spcPts val="500"/>
         </a:spcBef>
-        <a:buFont typeface="Arial"/>
-        <a:buChar char="–"/>
-        <a:defRPr sz="2800" kern="1200">
+        <a:buClr>
+          <a:schemeClr val="accent1"/>
+        </a:buClr>
+        <a:buSzPct val="100000"/>
+        <a:buFont typeface="Arial" panose="020B0604020202020204" pitchFamily="34" charset="0"/>
+        <a:buChar char="•"/>
+        <a:defRPr sz="1600" kern="1200" cap="none" baseline="0">
           <a:solidFill>
             <a:schemeClr val="tx1"/>
           </a:solidFill>
+          <a:effectLst/>
           <a:latin typeface="+mn-lt"/>
           <a:ea typeface="+mn-ea"/>
           <a:cs typeface="+mn-cs"/>
         </a:defRPr>
       </a:lvl2pPr>
-      <a:lvl3pPr marL="1143000" indent="-228600" algn="l" defTabSz="457200" rtl="0" eaLnBrk="1" latinLnBrk="0" hangingPunct="1">
+      <a:lvl3pPr marL="1143000" indent="-228600" algn="l" defTabSz="685800" rtl="0" eaLnBrk="1" latinLnBrk="0" hangingPunct="1">
+        <a:lnSpc>
+          <a:spcPct val="120000"/>
+        </a:lnSpc>
         <a:spcBef>
-          <a:spcPct val="20000"/>
+          <a:spcPts val="500"/>
         </a:spcBef>
-        <a:buFont typeface="Arial"/>
+        <a:buClr>
+          <a:schemeClr val="accent1"/>
+        </a:buClr>
+        <a:buSzPct val="100000"/>
+        <a:buFont typeface="Arial" panose="020B0604020202020204" pitchFamily="34" charset="0"/>
         <a:buChar char="•"/>
-        <a:defRPr sz="2400" kern="1200">
+        <a:defRPr sz="1600" kern="1200" cap="none">
           <a:solidFill>
             <a:schemeClr val="tx1"/>
           </a:solidFill>
+          <a:effectLst/>
           <a:latin typeface="+mn-lt"/>
           <a:ea typeface="+mn-ea"/>
           <a:cs typeface="+mn-cs"/>
         </a:defRPr>
       </a:lvl3pPr>
-      <a:lvl4pPr marL="1600200" indent="-228600" algn="l" defTabSz="457200" rtl="0" eaLnBrk="1" latinLnBrk="0" hangingPunct="1">
+      <a:lvl4pPr marL="1600200" indent="-228600" algn="l" defTabSz="685800" rtl="0" eaLnBrk="1" latinLnBrk="0" hangingPunct="1">
+        <a:lnSpc>
+          <a:spcPct val="120000"/>
+        </a:lnSpc>
         <a:spcBef>
-          <a:spcPct val="20000"/>
+          <a:spcPts val="500"/>
         </a:spcBef>
-        <a:buFont typeface="Arial"/>
-        <a:buChar char="–"/>
-        <a:defRPr sz="2000" kern="1200">
+        <a:buClr>
+          <a:schemeClr val="accent1"/>
+        </a:buClr>
+        <a:buSzPct val="100000"/>
+        <a:buFont typeface="Arial" panose="020B0604020202020204" pitchFamily="34" charset="0"/>
+        <a:buChar char="•"/>
+        <a:defRPr sz="1400" kern="1200" cap="none" baseline="0">
           <a:solidFill>
             <a:schemeClr val="tx1"/>
           </a:solidFill>
+          <a:effectLst/>
           <a:latin typeface="+mn-lt"/>
           <a:ea typeface="+mn-ea"/>
           <a:cs typeface="+mn-cs"/>
         </a:defRPr>
       </a:lvl4pPr>
-      <a:lvl5pPr marL="2057400" indent="-228600" algn="l" defTabSz="457200" rtl="0" eaLnBrk="1" latinLnBrk="0" hangingPunct="1">
+      <a:lvl5pPr marL="2057400" indent="-228600" algn="l" defTabSz="685800" rtl="0" eaLnBrk="1" latinLnBrk="0" hangingPunct="1">
+        <a:lnSpc>
+          <a:spcPct val="120000"/>
+        </a:lnSpc>
         <a:spcBef>
-          <a:spcPct val="20000"/>
+          <a:spcPts val="500"/>
         </a:spcBef>
-        <a:buFont typeface="Arial"/>
-        <a:buChar char="»"/>
-        <a:defRPr sz="2000" kern="1200">
+        <a:buClr>
+          <a:schemeClr val="accent1"/>
+        </a:buClr>
+        <a:buSzPct val="100000"/>
+        <a:buFont typeface="Arial" panose="020B0604020202020204" pitchFamily="34" charset="0"/>
+        <a:buChar char="•"/>
+        <a:defRPr sz="1200" kern="1200" cap="none">
           <a:solidFill>
             <a:schemeClr val="tx1"/>
           </a:solidFill>
+          <a:effectLst/>
           <a:latin typeface="+mn-lt"/>
           <a:ea typeface="+mn-ea"/>
           <a:cs typeface="+mn-cs"/>
         </a:defRPr>
       </a:lvl5pPr>
-      <a:lvl6pPr marL="2514600" indent="-228600" algn="l" defTabSz="457200" rtl="0" eaLnBrk="1" latinLnBrk="0" hangingPunct="1">
+      <a:lvl6pPr marL="2514600" indent="-228600" algn="l" defTabSz="914400" rtl="0" eaLnBrk="1" latinLnBrk="0" hangingPunct="1">
+        <a:lnSpc>
+          <a:spcPct val="120000"/>
+        </a:lnSpc>
         <a:spcBef>
-          <a:spcPct val="20000"/>
+          <a:spcPts val="500"/>
         </a:spcBef>
-        <a:buFont typeface="Arial"/>
+        <a:buClr>
+          <a:schemeClr val="accent1"/>
+        </a:buClr>
+        <a:buSzPct val="100000"/>
+        <a:buFont typeface="Arial" panose="020B0604020202020204" pitchFamily="34" charset="0"/>
         <a:buChar char="•"/>
-        <a:defRPr sz="2000" kern="1200">
+        <a:defRPr sz="1200" kern="1200">
           <a:solidFill>
             <a:schemeClr val="tx1"/>
           </a:solidFill>
+          <a:effectLst/>
           <a:latin typeface="+mn-lt"/>
           <a:ea typeface="+mn-ea"/>
           <a:cs typeface="+mn-cs"/>
         </a:defRPr>
       </a:lvl6pPr>
-      <a:lvl7pPr marL="2971800" indent="-228600" algn="l" defTabSz="457200" rtl="0" eaLnBrk="1" latinLnBrk="0" hangingPunct="1">
+      <a:lvl7pPr marL="2971800" indent="-228600" algn="l" defTabSz="914400" rtl="0" eaLnBrk="1" latinLnBrk="0" hangingPunct="1">
+        <a:lnSpc>
+          <a:spcPct val="120000"/>
+        </a:lnSpc>
         <a:spcBef>
-          <a:spcPct val="20000"/>
+          <a:spcPts val="500"/>
         </a:spcBef>
-        <a:buFont typeface="Arial"/>
+        <a:buClr>
+          <a:schemeClr val="accent1"/>
+        </a:buClr>
+        <a:buSzPct val="100000"/>
+        <a:buFont typeface="Arial" panose="020B0604020202020204" pitchFamily="34" charset="0"/>
         <a:buChar char="•"/>
-        <a:defRPr sz="2000" kern="1200">
+        <a:defRPr sz="1200" kern="1200">
           <a:solidFill>
             <a:schemeClr val="tx1"/>
           </a:solidFill>
+          <a:effectLst/>
           <a:latin typeface="+mn-lt"/>
           <a:ea typeface="+mn-ea"/>
           <a:cs typeface="+mn-cs"/>
         </a:defRPr>
       </a:lvl7pPr>
-      <a:lvl8pPr marL="3429000" indent="-228600" algn="l" defTabSz="457200" rtl="0" eaLnBrk="1" latinLnBrk="0" hangingPunct="1">
+      <a:lvl8pPr marL="3429000" indent="-228600" algn="l" defTabSz="914400" rtl="0" eaLnBrk="1" latinLnBrk="0" hangingPunct="1">
+        <a:lnSpc>
+          <a:spcPct val="120000"/>
+        </a:lnSpc>
         <a:spcBef>
-          <a:spcPct val="20000"/>
+          <a:spcPts val="500"/>
         </a:spcBef>
-        <a:buFont typeface="Arial"/>
+        <a:buClr>
+          <a:schemeClr val="accent1"/>
+        </a:buClr>
+        <a:buSzPct val="100000"/>
+        <a:buFont typeface="Arial" panose="020B0604020202020204" pitchFamily="34" charset="0"/>
         <a:buChar char="•"/>
-        <a:defRPr sz="2000" kern="1200">
+        <a:defRPr sz="1200" kern="1200" baseline="0">
           <a:solidFill>
             <a:schemeClr val="tx1"/>
           </a:solidFill>
+          <a:effectLst/>
           <a:latin typeface="+mn-lt"/>
           <a:ea typeface="+mn-ea"/>
           <a:cs typeface="+mn-cs"/>
         </a:defRPr>
       </a:lvl8pPr>
-      <a:lvl9pPr marL="3886200" indent="-228600" algn="l" defTabSz="457200" rtl="0" eaLnBrk="1" latinLnBrk="0" hangingPunct="1">
+      <a:lvl9pPr marL="3886200" indent="-228600" algn="l" defTabSz="914400" rtl="0" eaLnBrk="1" latinLnBrk="0" hangingPunct="1">
+        <a:lnSpc>
+          <a:spcPct val="120000"/>
+        </a:lnSpc>
         <a:spcBef>
-          <a:spcPct val="20000"/>
+          <a:spcPts val="500"/>
         </a:spcBef>
-        <a:buFont typeface="Arial"/>
+        <a:buClr>
+          <a:schemeClr val="accent1"/>
+        </a:buClr>
+        <a:buSzPct val="100000"/>
+        <a:buFont typeface="Arial" panose="020B0604020202020204" pitchFamily="34" charset="0"/>
         <a:buChar char="•"/>
-        <a:defRPr sz="2000" kern="1200">
+        <a:defRPr sz="1200" kern="1200" baseline="0">
           <a:solidFill>
             <a:schemeClr val="tx1"/>
           </a:solidFill>
+          <a:effectLst/>
           <a:latin typeface="+mn-lt"/>
           <a:ea typeface="+mn-ea"/>
           <a:cs typeface="+mn-cs"/>
@@ -3001,8 +3544,8 @@
       <a:defPPr>
         <a:defRPr lang="en-US"/>
       </a:defPPr>
-      <a:lvl1pPr marL="0" algn="l" defTabSz="457200" rtl="0" eaLnBrk="1" latinLnBrk="0" hangingPunct="1">
-        <a:defRPr sz="1800" kern="1200">
+      <a:lvl1pPr marL="0" algn="l" defTabSz="685800" rtl="0" eaLnBrk="1" latinLnBrk="0" hangingPunct="1">
+        <a:defRPr sz="1350" kern="1200">
           <a:solidFill>
             <a:schemeClr val="tx1"/>
           </a:solidFill>
@@ -3011,8 +3554,8 @@
           <a:cs typeface="+mn-cs"/>
         </a:defRPr>
       </a:lvl1pPr>
-      <a:lvl2pPr marL="457200" algn="l" defTabSz="457200" rtl="0" eaLnBrk="1" latinLnBrk="0" hangingPunct="1">
-        <a:defRPr sz="1800" kern="1200">
+      <a:lvl2pPr marL="342900" algn="l" defTabSz="685800" rtl="0" eaLnBrk="1" latinLnBrk="0" hangingPunct="1">
+        <a:defRPr sz="1350" kern="1200">
           <a:solidFill>
             <a:schemeClr val="tx1"/>
           </a:solidFill>
@@ -3021,8 +3564,8 @@
           <a:cs typeface="+mn-cs"/>
         </a:defRPr>
       </a:lvl2pPr>
-      <a:lvl3pPr marL="914400" algn="l" defTabSz="457200" rtl="0" eaLnBrk="1" latinLnBrk="0" hangingPunct="1">
-        <a:defRPr sz="1800" kern="1200">
+      <a:lvl3pPr marL="685800" algn="l" defTabSz="685800" rtl="0" eaLnBrk="1" latinLnBrk="0" hangingPunct="1">
+        <a:defRPr sz="1350" kern="1200">
           <a:solidFill>
             <a:schemeClr val="tx1"/>
           </a:solidFill>
@@ -3031,8 +3574,8 @@
           <a:cs typeface="+mn-cs"/>
         </a:defRPr>
       </a:lvl3pPr>
-      <a:lvl4pPr marL="1371600" algn="l" defTabSz="457200" rtl="0" eaLnBrk="1" latinLnBrk="0" hangingPunct="1">
-        <a:defRPr sz="1800" kern="1200">
+      <a:lvl4pPr marL="1028700" algn="l" defTabSz="685800" rtl="0" eaLnBrk="1" latinLnBrk="0" hangingPunct="1">
+        <a:defRPr sz="1350" kern="1200">
           <a:solidFill>
             <a:schemeClr val="tx1"/>
           </a:solidFill>
@@ -3041,8 +3584,8 @@
           <a:cs typeface="+mn-cs"/>
         </a:defRPr>
       </a:lvl4pPr>
-      <a:lvl5pPr marL="1828800" algn="l" defTabSz="457200" rtl="0" eaLnBrk="1" latinLnBrk="0" hangingPunct="1">
-        <a:defRPr sz="1800" kern="1200">
+      <a:lvl5pPr marL="1371600" algn="l" defTabSz="685800" rtl="0" eaLnBrk="1" latinLnBrk="0" hangingPunct="1">
+        <a:defRPr sz="1350" kern="1200">
           <a:solidFill>
             <a:schemeClr val="tx1"/>
           </a:solidFill>
@@ -3051,8 +3594,8 @@
           <a:cs typeface="+mn-cs"/>
         </a:defRPr>
       </a:lvl5pPr>
-      <a:lvl6pPr marL="2286000" algn="l" defTabSz="457200" rtl="0" eaLnBrk="1" latinLnBrk="0" hangingPunct="1">
-        <a:defRPr sz="1800" kern="1200">
+      <a:lvl6pPr marL="1714500" algn="l" defTabSz="685800" rtl="0" eaLnBrk="1" latinLnBrk="0" hangingPunct="1">
+        <a:defRPr sz="1350" kern="1200">
           <a:solidFill>
             <a:schemeClr val="tx1"/>
           </a:solidFill>
@@ -3061,8 +3604,8 @@
           <a:cs typeface="+mn-cs"/>
         </a:defRPr>
       </a:lvl6pPr>
-      <a:lvl7pPr marL="2743200" algn="l" defTabSz="457200" rtl="0" eaLnBrk="1" latinLnBrk="0" hangingPunct="1">
-        <a:defRPr sz="1800" kern="1200">
+      <a:lvl7pPr marL="2057400" algn="l" defTabSz="685800" rtl="0" eaLnBrk="1" latinLnBrk="0" hangingPunct="1">
+        <a:defRPr sz="1350" kern="1200">
           <a:solidFill>
             <a:schemeClr val="tx1"/>
           </a:solidFill>
@@ -3071,8 +3614,8 @@
           <a:cs typeface="+mn-cs"/>
         </a:defRPr>
       </a:lvl7pPr>
-      <a:lvl8pPr marL="3200400" algn="l" defTabSz="457200" rtl="0" eaLnBrk="1" latinLnBrk="0" hangingPunct="1">
-        <a:defRPr sz="1800" kern="1200">
+      <a:lvl8pPr marL="2400300" algn="l" defTabSz="685800" rtl="0" eaLnBrk="1" latinLnBrk="0" hangingPunct="1">
+        <a:defRPr sz="1350" kern="1200">
           <a:solidFill>
             <a:schemeClr val="tx1"/>
           </a:solidFill>
@@ -3081,8 +3624,8 @@
           <a:cs typeface="+mn-cs"/>
         </a:defRPr>
       </a:lvl8pPr>
-      <a:lvl9pPr marL="3657600" algn="l" defTabSz="457200" rtl="0" eaLnBrk="1" latinLnBrk="0" hangingPunct="1">
-        <a:defRPr sz="1800" kern="1200">
+      <a:lvl9pPr marL="2743200" algn="l" defTabSz="685800" rtl="0" eaLnBrk="1" latinLnBrk="0" hangingPunct="1">
+        <a:defRPr sz="1350" kern="1200">
           <a:solidFill>
             <a:schemeClr val="tx1"/>
           </a:solidFill>
@@ -3097,7 +3640,7 @@
 </file>
 
 <file path=ppt/slides/slide1.xml><?xml version="1.0" encoding="utf-8"?>
-<p:sld xmlns:a="http://schemas.openxmlformats.org/drawingml/2006/main" xmlns:p="http://schemas.openxmlformats.org/presentationml/2006/main" xmlns:r="http://schemas.openxmlformats.org/officeDocument/2006/relationships">
+<p:sld xmlns:a="http://schemas.openxmlformats.org/drawingml/2006/main" xmlns:r="http://schemas.openxmlformats.org/officeDocument/2006/relationships" xmlns:p="http://schemas.openxmlformats.org/presentationml/2006/main">
   <p:cSld>
     <p:spTree>
       <p:nvGrpSpPr>
@@ -3105,7 +3648,14 @@
         <p:cNvGrpSpPr/>
         <p:nvPr/>
       </p:nvGrpSpPr>
-      <p:grpSpPr/>
+      <p:grpSpPr>
+        <a:xfrm>
+          <a:off x="0" y="0"/>
+          <a:ext cx="0" cy="0"/>
+          <a:chOff x="0" y="0"/>
+          <a:chExt cx="0" cy="0"/>
+        </a:xfrm>
+      </p:grpSpPr>
       <p:sp>
         <p:nvSpPr>
           <p:cNvPr id="2" name="Title 1"/>
@@ -3118,7 +3668,9 @@
         </p:nvSpPr>
         <p:spPr/>
         <p:txBody>
-          <a:bodyPr/>
+          <a:bodyPr>
+            <a:normAutofit fontScale="90000"/>
+          </a:bodyPr>
           <a:lstStyle/>
           <a:p>
             <a:r>
@@ -3157,7 +3709,7 @@
 </file>
 
 <file path=ppt/slides/slide10.xml><?xml version="1.0" encoding="utf-8"?>
-<p:sld xmlns:a="http://schemas.openxmlformats.org/drawingml/2006/main" xmlns:p="http://schemas.openxmlformats.org/presentationml/2006/main" xmlns:r="http://schemas.openxmlformats.org/officeDocument/2006/relationships">
+<p:sld xmlns:a="http://schemas.openxmlformats.org/drawingml/2006/main" xmlns:r="http://schemas.openxmlformats.org/officeDocument/2006/relationships" xmlns:p="http://schemas.openxmlformats.org/presentationml/2006/main">
   <p:cSld>
     <p:spTree>
       <p:nvGrpSpPr>
@@ -3165,7 +3717,14 @@
         <p:cNvGrpSpPr/>
         <p:nvPr/>
       </p:nvGrpSpPr>
-      <p:grpSpPr/>
+      <p:grpSpPr>
+        <a:xfrm>
+          <a:off x="0" y="0"/>
+          <a:ext cx="0" cy="0"/>
+          <a:chOff x="0" y="0"/>
+          <a:chExt cx="0" cy="0"/>
+        </a:xfrm>
+      </p:grpSpPr>
       <p:sp>
         <p:nvSpPr>
           <p:cNvPr id="2" name="Title 1"/>
@@ -3227,7 +3786,7 @@
 </file>
 
 <file path=ppt/slides/slide11.xml><?xml version="1.0" encoding="utf-8"?>
-<p:sld xmlns:a="http://schemas.openxmlformats.org/drawingml/2006/main" xmlns:p="http://schemas.openxmlformats.org/presentationml/2006/main" xmlns:r="http://schemas.openxmlformats.org/officeDocument/2006/relationships">
+<p:sld xmlns:a="http://schemas.openxmlformats.org/drawingml/2006/main" xmlns:r="http://schemas.openxmlformats.org/officeDocument/2006/relationships" xmlns:p="http://schemas.openxmlformats.org/presentationml/2006/main">
   <p:cSld>
     <p:spTree>
       <p:nvGrpSpPr>
@@ -3235,7 +3794,14 @@
         <p:cNvGrpSpPr/>
         <p:nvPr/>
       </p:nvGrpSpPr>
-      <p:grpSpPr/>
+      <p:grpSpPr>
+        <a:xfrm>
+          <a:off x="0" y="0"/>
+          <a:ext cx="0" cy="0"/>
+          <a:chOff x="0" y="0"/>
+          <a:chExt cx="0" cy="0"/>
+        </a:xfrm>
+      </p:grpSpPr>
       <p:sp>
         <p:nvSpPr>
           <p:cNvPr id="2" name="Title 1"/>
@@ -3297,7 +3863,7 @@
 </file>
 
 <file path=ppt/slides/slide12.xml><?xml version="1.0" encoding="utf-8"?>
-<p:sld xmlns:a="http://schemas.openxmlformats.org/drawingml/2006/main" xmlns:p="http://schemas.openxmlformats.org/presentationml/2006/main" xmlns:r="http://schemas.openxmlformats.org/officeDocument/2006/relationships">
+<p:sld xmlns:a="http://schemas.openxmlformats.org/drawingml/2006/main" xmlns:r="http://schemas.openxmlformats.org/officeDocument/2006/relationships" xmlns:p="http://schemas.openxmlformats.org/presentationml/2006/main">
   <p:cSld>
     <p:spTree>
       <p:nvGrpSpPr>
@@ -3305,7 +3871,14 @@
         <p:cNvGrpSpPr/>
         <p:nvPr/>
       </p:nvGrpSpPr>
-      <p:grpSpPr/>
+      <p:grpSpPr>
+        <a:xfrm>
+          <a:off x="0" y="0"/>
+          <a:ext cx="0" cy="0"/>
+          <a:chOff x="0" y="0"/>
+          <a:chExt cx="0" cy="0"/>
+        </a:xfrm>
+      </p:grpSpPr>
       <p:sp>
         <p:nvSpPr>
           <p:cNvPr id="2" name="Title 1"/>
@@ -3367,7 +3940,7 @@
 </file>
 
 <file path=ppt/slides/slide13.xml><?xml version="1.0" encoding="utf-8"?>
-<p:sld xmlns:a="http://schemas.openxmlformats.org/drawingml/2006/main" xmlns:p="http://schemas.openxmlformats.org/presentationml/2006/main" xmlns:r="http://schemas.openxmlformats.org/officeDocument/2006/relationships">
+<p:sld xmlns:a="http://schemas.openxmlformats.org/drawingml/2006/main" xmlns:r="http://schemas.openxmlformats.org/officeDocument/2006/relationships" xmlns:p="http://schemas.openxmlformats.org/presentationml/2006/main">
   <p:cSld>
     <p:spTree>
       <p:nvGrpSpPr>
@@ -3375,7 +3948,14 @@
         <p:cNvGrpSpPr/>
         <p:nvPr/>
       </p:nvGrpSpPr>
-      <p:grpSpPr/>
+      <p:grpSpPr>
+        <a:xfrm>
+          <a:off x="0" y="0"/>
+          <a:ext cx="0" cy="0"/>
+          <a:chOff x="0" y="0"/>
+          <a:chExt cx="0" cy="0"/>
+        </a:xfrm>
+      </p:grpSpPr>
       <p:sp>
         <p:nvSpPr>
           <p:cNvPr id="2" name="Title 1"/>
@@ -3437,7 +4017,7 @@
 </file>
 
 <file path=ppt/slides/slide14.xml><?xml version="1.0" encoding="utf-8"?>
-<p:sld xmlns:a="http://schemas.openxmlformats.org/drawingml/2006/main" xmlns:p="http://schemas.openxmlformats.org/presentationml/2006/main" xmlns:r="http://schemas.openxmlformats.org/officeDocument/2006/relationships">
+<p:sld xmlns:a="http://schemas.openxmlformats.org/drawingml/2006/main" xmlns:r="http://schemas.openxmlformats.org/officeDocument/2006/relationships" xmlns:p="http://schemas.openxmlformats.org/presentationml/2006/main">
   <p:cSld>
     <p:spTree>
       <p:nvGrpSpPr>
@@ -3445,7 +4025,14 @@
         <p:cNvGrpSpPr/>
         <p:nvPr/>
       </p:nvGrpSpPr>
-      <p:grpSpPr/>
+      <p:grpSpPr>
+        <a:xfrm>
+          <a:off x="0" y="0"/>
+          <a:ext cx="0" cy="0"/>
+          <a:chOff x="0" y="0"/>
+          <a:chExt cx="0" cy="0"/>
+        </a:xfrm>
+      </p:grpSpPr>
       <p:sp>
         <p:nvSpPr>
           <p:cNvPr id="2" name="Title 1"/>
@@ -3507,7 +4094,7 @@
 </file>
 
 <file path=ppt/slides/slide15.xml><?xml version="1.0" encoding="utf-8"?>
-<p:sld xmlns:a="http://schemas.openxmlformats.org/drawingml/2006/main" xmlns:p="http://schemas.openxmlformats.org/presentationml/2006/main" xmlns:r="http://schemas.openxmlformats.org/officeDocument/2006/relationships">
+<p:sld xmlns:a="http://schemas.openxmlformats.org/drawingml/2006/main" xmlns:r="http://schemas.openxmlformats.org/officeDocument/2006/relationships" xmlns:p="http://schemas.openxmlformats.org/presentationml/2006/main">
   <p:cSld>
     <p:spTree>
       <p:nvGrpSpPr>
@@ -3515,7 +4102,14 @@
         <p:cNvGrpSpPr/>
         <p:nvPr/>
       </p:nvGrpSpPr>
-      <p:grpSpPr/>
+      <p:grpSpPr>
+        <a:xfrm>
+          <a:off x="0" y="0"/>
+          <a:ext cx="0" cy="0"/>
+          <a:chOff x="0" y="0"/>
+          <a:chExt cx="0" cy="0"/>
+        </a:xfrm>
+      </p:grpSpPr>
       <p:sp>
         <p:nvSpPr>
           <p:cNvPr id="2" name="Title 1"/>
@@ -3577,7 +4171,7 @@
 </file>
 
 <file path=ppt/slides/slide16.xml><?xml version="1.0" encoding="utf-8"?>
-<p:sld xmlns:a="http://schemas.openxmlformats.org/drawingml/2006/main" xmlns:p="http://schemas.openxmlformats.org/presentationml/2006/main" xmlns:r="http://schemas.openxmlformats.org/officeDocument/2006/relationships">
+<p:sld xmlns:a="http://schemas.openxmlformats.org/drawingml/2006/main" xmlns:r="http://schemas.openxmlformats.org/officeDocument/2006/relationships" xmlns:p="http://schemas.openxmlformats.org/presentationml/2006/main">
   <p:cSld>
     <p:spTree>
       <p:nvGrpSpPr>
@@ -3585,7 +4179,14 @@
         <p:cNvGrpSpPr/>
         <p:nvPr/>
       </p:nvGrpSpPr>
-      <p:grpSpPr/>
+      <p:grpSpPr>
+        <a:xfrm>
+          <a:off x="0" y="0"/>
+          <a:ext cx="0" cy="0"/>
+          <a:chOff x="0" y="0"/>
+          <a:chExt cx="0" cy="0"/>
+        </a:xfrm>
+      </p:grpSpPr>
       <p:sp>
         <p:nvSpPr>
           <p:cNvPr id="2" name="Title 1"/>
@@ -3647,7 +4248,7 @@
 </file>
 
 <file path=ppt/slides/slide17.xml><?xml version="1.0" encoding="utf-8"?>
-<p:sld xmlns:a="http://schemas.openxmlformats.org/drawingml/2006/main" xmlns:p="http://schemas.openxmlformats.org/presentationml/2006/main" xmlns:r="http://schemas.openxmlformats.org/officeDocument/2006/relationships">
+<p:sld xmlns:a="http://schemas.openxmlformats.org/drawingml/2006/main" xmlns:r="http://schemas.openxmlformats.org/officeDocument/2006/relationships" xmlns:p="http://schemas.openxmlformats.org/presentationml/2006/main">
   <p:cSld>
     <p:spTree>
       <p:nvGrpSpPr>
@@ -3655,7 +4256,14 @@
         <p:cNvGrpSpPr/>
         <p:nvPr/>
       </p:nvGrpSpPr>
-      <p:grpSpPr/>
+      <p:grpSpPr>
+        <a:xfrm>
+          <a:off x="0" y="0"/>
+          <a:ext cx="0" cy="0"/>
+          <a:chOff x="0" y="0"/>
+          <a:chExt cx="0" cy="0"/>
+        </a:xfrm>
+      </p:grpSpPr>
       <p:sp>
         <p:nvSpPr>
           <p:cNvPr id="2" name="Title 1"/>
@@ -3717,7 +4325,7 @@
 </file>
 
 <file path=ppt/slides/slide18.xml><?xml version="1.0" encoding="utf-8"?>
-<p:sld xmlns:a="http://schemas.openxmlformats.org/drawingml/2006/main" xmlns:p="http://schemas.openxmlformats.org/presentationml/2006/main" xmlns:r="http://schemas.openxmlformats.org/officeDocument/2006/relationships">
+<p:sld xmlns:a="http://schemas.openxmlformats.org/drawingml/2006/main" xmlns:r="http://schemas.openxmlformats.org/officeDocument/2006/relationships" xmlns:p="http://schemas.openxmlformats.org/presentationml/2006/main">
   <p:cSld>
     <p:spTree>
       <p:nvGrpSpPr>
@@ -3725,7 +4333,14 @@
         <p:cNvGrpSpPr/>
         <p:nvPr/>
       </p:nvGrpSpPr>
-      <p:grpSpPr/>
+      <p:grpSpPr>
+        <a:xfrm>
+          <a:off x="0" y="0"/>
+          <a:ext cx="0" cy="0"/>
+          <a:chOff x="0" y="0"/>
+          <a:chExt cx="0" cy="0"/>
+        </a:xfrm>
+      </p:grpSpPr>
       <p:sp>
         <p:nvSpPr>
           <p:cNvPr id="2" name="Title 1"/>
@@ -3787,7 +4402,7 @@
 </file>
 
 <file path=ppt/slides/slide19.xml><?xml version="1.0" encoding="utf-8"?>
-<p:sld xmlns:a="http://schemas.openxmlformats.org/drawingml/2006/main" xmlns:p="http://schemas.openxmlformats.org/presentationml/2006/main" xmlns:r="http://schemas.openxmlformats.org/officeDocument/2006/relationships">
+<p:sld xmlns:a="http://schemas.openxmlformats.org/drawingml/2006/main" xmlns:r="http://schemas.openxmlformats.org/officeDocument/2006/relationships" xmlns:p="http://schemas.openxmlformats.org/presentationml/2006/main">
   <p:cSld>
     <p:spTree>
       <p:nvGrpSpPr>
@@ -3795,7 +4410,14 @@
         <p:cNvGrpSpPr/>
         <p:nvPr/>
       </p:nvGrpSpPr>
-      <p:grpSpPr/>
+      <p:grpSpPr>
+        <a:xfrm>
+          <a:off x="0" y="0"/>
+          <a:ext cx="0" cy="0"/>
+          <a:chOff x="0" y="0"/>
+          <a:chExt cx="0" cy="0"/>
+        </a:xfrm>
+      </p:grpSpPr>
       <p:sp>
         <p:nvSpPr>
           <p:cNvPr id="2" name="Title 1"/>
@@ -3862,7 +4484,7 @@
 </file>
 
 <file path=ppt/slides/slide2.xml><?xml version="1.0" encoding="utf-8"?>
-<p:sld xmlns:a="http://schemas.openxmlformats.org/drawingml/2006/main" xmlns:p="http://schemas.openxmlformats.org/presentationml/2006/main" xmlns:r="http://schemas.openxmlformats.org/officeDocument/2006/relationships">
+<p:sld xmlns:a="http://schemas.openxmlformats.org/drawingml/2006/main" xmlns:r="http://schemas.openxmlformats.org/officeDocument/2006/relationships" xmlns:p="http://schemas.openxmlformats.org/presentationml/2006/main">
   <p:cSld>
     <p:spTree>
       <p:nvGrpSpPr>
@@ -3870,7 +4492,14 @@
         <p:cNvGrpSpPr/>
         <p:nvPr/>
       </p:nvGrpSpPr>
-      <p:grpSpPr/>
+      <p:grpSpPr>
+        <a:xfrm>
+          <a:off x="0" y="0"/>
+          <a:ext cx="0" cy="0"/>
+          <a:chOff x="0" y="0"/>
+          <a:chExt cx="0" cy="0"/>
+        </a:xfrm>
+      </p:grpSpPr>
       <p:sp>
         <p:nvSpPr>
           <p:cNvPr id="2" name="Title 1"/>
@@ -3927,7 +4556,7 @@
 </file>
 
 <file path=ppt/slides/slide3.xml><?xml version="1.0" encoding="utf-8"?>
-<p:sld xmlns:a="http://schemas.openxmlformats.org/drawingml/2006/main" xmlns:p="http://schemas.openxmlformats.org/presentationml/2006/main" xmlns:r="http://schemas.openxmlformats.org/officeDocument/2006/relationships">
+<p:sld xmlns:a="http://schemas.openxmlformats.org/drawingml/2006/main" xmlns:r="http://schemas.openxmlformats.org/officeDocument/2006/relationships" xmlns:p="http://schemas.openxmlformats.org/presentationml/2006/main">
   <p:cSld>
     <p:spTree>
       <p:nvGrpSpPr>
@@ -3935,7 +4564,14 @@
         <p:cNvGrpSpPr/>
         <p:nvPr/>
       </p:nvGrpSpPr>
-      <p:grpSpPr/>
+      <p:grpSpPr>
+        <a:xfrm>
+          <a:off x="0" y="0"/>
+          <a:ext cx="0" cy="0"/>
+          <a:chOff x="0" y="0"/>
+          <a:chExt cx="0" cy="0"/>
+        </a:xfrm>
+      </p:grpSpPr>
       <p:sp>
         <p:nvSpPr>
           <p:cNvPr id="2" name="Title 1"/>
@@ -3997,7 +4633,7 @@
 </file>
 
 <file path=ppt/slides/slide4.xml><?xml version="1.0" encoding="utf-8"?>
-<p:sld xmlns:a="http://schemas.openxmlformats.org/drawingml/2006/main" xmlns:p="http://schemas.openxmlformats.org/presentationml/2006/main" xmlns:r="http://schemas.openxmlformats.org/officeDocument/2006/relationships">
+<p:sld xmlns:a="http://schemas.openxmlformats.org/drawingml/2006/main" xmlns:r="http://schemas.openxmlformats.org/officeDocument/2006/relationships" xmlns:p="http://schemas.openxmlformats.org/presentationml/2006/main">
   <p:cSld>
     <p:spTree>
       <p:nvGrpSpPr>
@@ -4005,7 +4641,14 @@
         <p:cNvGrpSpPr/>
         <p:nvPr/>
       </p:nvGrpSpPr>
-      <p:grpSpPr/>
+      <p:grpSpPr>
+        <a:xfrm>
+          <a:off x="0" y="0"/>
+          <a:ext cx="0" cy="0"/>
+          <a:chOff x="0" y="0"/>
+          <a:chExt cx="0" cy="0"/>
+        </a:xfrm>
+      </p:grpSpPr>
       <p:sp>
         <p:nvSpPr>
           <p:cNvPr id="2" name="Title 1"/>
@@ -4067,7 +4710,7 @@
 </file>
 
 <file path=ppt/slides/slide5.xml><?xml version="1.0" encoding="utf-8"?>
-<p:sld xmlns:a="http://schemas.openxmlformats.org/drawingml/2006/main" xmlns:p="http://schemas.openxmlformats.org/presentationml/2006/main" xmlns:r="http://schemas.openxmlformats.org/officeDocument/2006/relationships">
+<p:sld xmlns:a="http://schemas.openxmlformats.org/drawingml/2006/main" xmlns:r="http://schemas.openxmlformats.org/officeDocument/2006/relationships" xmlns:p="http://schemas.openxmlformats.org/presentationml/2006/main">
   <p:cSld>
     <p:spTree>
       <p:nvGrpSpPr>
@@ -4075,7 +4718,14 @@
         <p:cNvGrpSpPr/>
         <p:nvPr/>
       </p:nvGrpSpPr>
-      <p:grpSpPr/>
+      <p:grpSpPr>
+        <a:xfrm>
+          <a:off x="0" y="0"/>
+          <a:ext cx="0" cy="0"/>
+          <a:chOff x="0" y="0"/>
+          <a:chExt cx="0" cy="0"/>
+        </a:xfrm>
+      </p:grpSpPr>
       <p:sp>
         <p:nvSpPr>
           <p:cNvPr id="2" name="Title 1"/>
@@ -4137,7 +4787,7 @@
 </file>
 
 <file path=ppt/slides/slide6.xml><?xml version="1.0" encoding="utf-8"?>
-<p:sld xmlns:a="http://schemas.openxmlformats.org/drawingml/2006/main" xmlns:p="http://schemas.openxmlformats.org/presentationml/2006/main" xmlns:r="http://schemas.openxmlformats.org/officeDocument/2006/relationships">
+<p:sld xmlns:a="http://schemas.openxmlformats.org/drawingml/2006/main" xmlns:r="http://schemas.openxmlformats.org/officeDocument/2006/relationships" xmlns:p="http://schemas.openxmlformats.org/presentationml/2006/main">
   <p:cSld>
     <p:spTree>
       <p:nvGrpSpPr>
@@ -4145,7 +4795,14 @@
         <p:cNvGrpSpPr/>
         <p:nvPr/>
       </p:nvGrpSpPr>
-      <p:grpSpPr/>
+      <p:grpSpPr>
+        <a:xfrm>
+          <a:off x="0" y="0"/>
+          <a:ext cx="0" cy="0"/>
+          <a:chOff x="0" y="0"/>
+          <a:chExt cx="0" cy="0"/>
+        </a:xfrm>
+      </p:grpSpPr>
       <p:sp>
         <p:nvSpPr>
           <p:cNvPr id="2" name="Title 1"/>
@@ -4207,7 +4864,7 @@
 </file>
 
 <file path=ppt/slides/slide7.xml><?xml version="1.0" encoding="utf-8"?>
-<p:sld xmlns:a="http://schemas.openxmlformats.org/drawingml/2006/main" xmlns:p="http://schemas.openxmlformats.org/presentationml/2006/main" xmlns:r="http://schemas.openxmlformats.org/officeDocument/2006/relationships">
+<p:sld xmlns:a="http://schemas.openxmlformats.org/drawingml/2006/main" xmlns:r="http://schemas.openxmlformats.org/officeDocument/2006/relationships" xmlns:p="http://schemas.openxmlformats.org/presentationml/2006/main">
   <p:cSld>
     <p:spTree>
       <p:nvGrpSpPr>
@@ -4215,7 +4872,14 @@
         <p:cNvGrpSpPr/>
         <p:nvPr/>
       </p:nvGrpSpPr>
-      <p:grpSpPr/>
+      <p:grpSpPr>
+        <a:xfrm>
+          <a:off x="0" y="0"/>
+          <a:ext cx="0" cy="0"/>
+          <a:chOff x="0" y="0"/>
+          <a:chExt cx="0" cy="0"/>
+        </a:xfrm>
+      </p:grpSpPr>
       <p:sp>
         <p:nvSpPr>
           <p:cNvPr id="2" name="Title 1"/>
@@ -4277,7 +4941,7 @@
 </file>
 
 <file path=ppt/slides/slide8.xml><?xml version="1.0" encoding="utf-8"?>
-<p:sld xmlns:a="http://schemas.openxmlformats.org/drawingml/2006/main" xmlns:p="http://schemas.openxmlformats.org/presentationml/2006/main" xmlns:r="http://schemas.openxmlformats.org/officeDocument/2006/relationships">
+<p:sld xmlns:a="http://schemas.openxmlformats.org/drawingml/2006/main" xmlns:r="http://schemas.openxmlformats.org/officeDocument/2006/relationships" xmlns:p="http://schemas.openxmlformats.org/presentationml/2006/main">
   <p:cSld>
     <p:spTree>
       <p:nvGrpSpPr>
@@ -4285,7 +4949,14 @@
         <p:cNvGrpSpPr/>
         <p:nvPr/>
       </p:nvGrpSpPr>
-      <p:grpSpPr/>
+      <p:grpSpPr>
+        <a:xfrm>
+          <a:off x="0" y="0"/>
+          <a:ext cx="0" cy="0"/>
+          <a:chOff x="0" y="0"/>
+          <a:chExt cx="0" cy="0"/>
+        </a:xfrm>
+      </p:grpSpPr>
       <p:sp>
         <p:nvSpPr>
           <p:cNvPr id="2" name="Title 1"/>
@@ -4347,7 +5018,7 @@
 </file>
 
 <file path=ppt/slides/slide9.xml><?xml version="1.0" encoding="utf-8"?>
-<p:sld xmlns:a="http://schemas.openxmlformats.org/drawingml/2006/main" xmlns:p="http://schemas.openxmlformats.org/presentationml/2006/main" xmlns:r="http://schemas.openxmlformats.org/officeDocument/2006/relationships">
+<p:sld xmlns:a="http://schemas.openxmlformats.org/drawingml/2006/main" xmlns:r="http://schemas.openxmlformats.org/officeDocument/2006/relationships" xmlns:p="http://schemas.openxmlformats.org/presentationml/2006/main">
   <p:cSld>
     <p:spTree>
       <p:nvGrpSpPr>
@@ -4355,7 +5026,14 @@
         <p:cNvGrpSpPr/>
         <p:nvPr/>
       </p:nvGrpSpPr>
-      <p:grpSpPr/>
+      <p:grpSpPr>
+        <a:xfrm>
+          <a:off x="0" y="0"/>
+          <a:ext cx="0" cy="0"/>
+          <a:chOff x="0" y="0"/>
+          <a:chExt cx="0" cy="0"/>
+        </a:xfrm>
+      </p:grpSpPr>
       <p:sp>
         <p:nvSpPr>
           <p:cNvPr id="2" name="Title 1"/>
@@ -4417,9 +5095,9 @@
 </file>
 
 <file path=ppt/theme/theme1.xml><?xml version="1.0" encoding="utf-8"?>
-<a:theme xmlns:a="http://schemas.openxmlformats.org/drawingml/2006/main" name="Office Theme">
+<a:theme xmlns:a="http://schemas.openxmlformats.org/drawingml/2006/main" name="Gallery">
   <a:themeElements>
-    <a:clrScheme name="Office">
+    <a:clrScheme name="Gallery">
       <a:dk1>
         <a:sysClr val="windowText" lastClr="000000"/>
       </a:dk1>
@@ -4427,44 +5105,44 @@
         <a:sysClr val="window" lastClr="FFFFFF"/>
       </a:lt1>
       <a:dk2>
-        <a:srgbClr val="1F497D"/>
+        <a:srgbClr val="454545"/>
       </a:dk2>
       <a:lt2>
-        <a:srgbClr val="EEECE1"/>
+        <a:srgbClr val="DFDBD5"/>
       </a:lt2>
       <a:accent1>
-        <a:srgbClr val="4F81BD"/>
+        <a:srgbClr val="B71E42"/>
       </a:accent1>
       <a:accent2>
-        <a:srgbClr val="C0504D"/>
+        <a:srgbClr val="DE478E"/>
       </a:accent2>
       <a:accent3>
-        <a:srgbClr val="9BBB59"/>
+        <a:srgbClr val="BC72F0"/>
       </a:accent3>
       <a:accent4>
-        <a:srgbClr val="8064A2"/>
+        <a:srgbClr val="795FAF"/>
       </a:accent4>
       <a:accent5>
-        <a:srgbClr val="4BACC6"/>
+        <a:srgbClr val="586EA6"/>
       </a:accent5>
       <a:accent6>
-        <a:srgbClr val="F79646"/>
+        <a:srgbClr val="6892A0"/>
       </a:accent6>
       <a:hlink>
-        <a:srgbClr val="0000FF"/>
+        <a:srgbClr val="FA2B5C"/>
       </a:hlink>
       <a:folHlink>
-        <a:srgbClr val="800080"/>
+        <a:srgbClr val="BC658E"/>
       </a:folHlink>
     </a:clrScheme>
-    <a:fontScheme name="Office">
+    <a:fontScheme name="Gallery">
       <a:majorFont>
-        <a:latin typeface="Calibri"/>
+        <a:latin typeface="Gill Sans MT" panose="020B0502020104020203"/>
         <a:ea typeface=""/>
         <a:cs typeface=""/>
-        <a:font script="Jpan" typeface="ＭＳ Ｐゴシック"/>
+        <a:font script="Jpan" typeface="游ゴシック Light"/>
         <a:font script="Hang" typeface="맑은 고딕"/>
-        <a:font script="Hans" typeface="宋体"/>
+        <a:font script="Hans" typeface="等线 Light"/>
         <a:font script="Hant" typeface="新細明體"/>
         <a:font script="Arab" typeface="Times New Roman"/>
         <a:font script="Hebr" typeface="Times New Roman"/>
@@ -4494,12 +5172,12 @@
         <a:font script="Geor" typeface="Sylfaen"/>
       </a:majorFont>
       <a:minorFont>
-        <a:latin typeface="Calibri"/>
+        <a:latin typeface="Gill Sans MT" panose="020B0502020104020203"/>
         <a:ea typeface=""/>
         <a:cs typeface=""/>
-        <a:font script="Jpan" typeface="ＭＳ Ｐゴシック"/>
+        <a:font script="Jpan" typeface="游ゴシック"/>
         <a:font script="Hang" typeface="맑은 고딕"/>
-        <a:font script="Hans" typeface="宋体"/>
+        <a:font script="Hans" typeface="等线"/>
         <a:font script="Hant" typeface="新細明體"/>
         <a:font script="Arab" typeface="Arial"/>
         <a:font script="Hebr" typeface="Arial"/>
@@ -4529,7 +5207,7 @@
         <a:font script="Geor" typeface="Sylfaen"/>
       </a:minorFont>
     </a:fontScheme>
-    <a:fmtScheme name="Office">
+    <a:fmtScheme name="Gallery">
       <a:fillStyleLst>
         <a:solidFill>
           <a:schemeClr val="phClr"/>
@@ -4538,62 +5216,64 @@
           <a:gsLst>
             <a:gs pos="0">
               <a:schemeClr val="phClr">
-                <a:tint val="50000"/>
-                <a:satMod val="300000"/>
-              </a:schemeClr>
-            </a:gs>
-            <a:gs pos="35000">
-              <a:schemeClr val="phClr">
-                <a:tint val="37000"/>
-                <a:satMod val="300000"/>
+                <a:tint val="54000"/>
+                <a:alpha val="100000"/>
+                <a:satMod val="105000"/>
+                <a:lumMod val="110000"/>
               </a:schemeClr>
             </a:gs>
             <a:gs pos="100000">
               <a:schemeClr val="phClr">
-                <a:tint val="15000"/>
-                <a:satMod val="350000"/>
+                <a:tint val="78000"/>
+                <a:alpha val="92000"/>
+                <a:satMod val="109000"/>
+                <a:lumMod val="100000"/>
               </a:schemeClr>
             </a:gs>
           </a:gsLst>
-          <a:lin ang="16200000" scaled="1"/>
+          <a:lin ang="5400000" scaled="0"/>
         </a:gradFill>
         <a:gradFill rotWithShape="1">
           <a:gsLst>
             <a:gs pos="0">
               <a:schemeClr val="phClr">
-                <a:tint val="100000"/>
-                <a:shade val="100000"/>
+                <a:tint val="98000"/>
+                <a:satMod val="110000"/>
+                <a:lumMod val="104000"/>
+              </a:schemeClr>
+            </a:gs>
+            <a:gs pos="69000">
+              <a:schemeClr val="phClr">
+                <a:shade val="88000"/>
                 <a:satMod val="130000"/>
+                <a:lumMod val="92000"/>
               </a:schemeClr>
             </a:gs>
             <a:gs pos="100000">
               <a:schemeClr val="phClr">
-                <a:tint val="50000"/>
-                <a:shade val="100000"/>
-                <a:satMod val="350000"/>
+                <a:shade val="78000"/>
+                <a:satMod val="130000"/>
+                <a:lumMod val="92000"/>
               </a:schemeClr>
             </a:gs>
           </a:gsLst>
-          <a:lin ang="16200000" scaled="0"/>
+          <a:lin ang="5400000" scaled="0"/>
         </a:gradFill>
       </a:fillStyleLst>
       <a:lnStyleLst>
         <a:ln w="9525" cap="flat" cmpd="sng" algn="ctr">
           <a:solidFill>
-            <a:schemeClr val="phClr">
-              <a:shade val="95000"/>
-              <a:satMod val="105000"/>
-            </a:schemeClr>
+            <a:schemeClr val="phClr"/>
           </a:solidFill>
           <a:prstDash val="solid"/>
         </a:ln>
-        <a:ln w="25400" cap="flat" cmpd="sng" algn="ctr">
+        <a:ln w="15875" cap="flat" cmpd="sng" algn="ctr">
           <a:solidFill>
             <a:schemeClr val="phClr"/>
           </a:solidFill>
           <a:prstDash val="solid"/>
         </a:ln>
-        <a:ln w="38100" cap="flat" cmpd="sng" algn="ctr">
+        <a:ln w="22225" cap="flat" cmpd="sng" algn="ctr">
           <a:solidFill>
             <a:schemeClr val="phClr"/>
           </a:solidFill>
@@ -4602,28 +5282,16 @@
       </a:lnStyleLst>
       <a:effectStyleLst>
         <a:effectStyle>
-          <a:effectLst>
-            <a:outerShdw blurRad="40000" dist="20000" dir="5400000" rotWithShape="0">
-              <a:srgbClr val="000000">
-                <a:alpha val="38000"/>
-              </a:srgbClr>
-            </a:outerShdw>
-          </a:effectLst>
+          <a:effectLst/>
+        </a:effectStyle>
+        <a:effectStyle>
+          <a:effectLst/>
         </a:effectStyle>
         <a:effectStyle>
           <a:effectLst>
-            <a:outerShdw blurRad="40000" dist="23000" dir="5400000" rotWithShape="0">
+            <a:outerShdw blurRad="50800" dist="50800" dir="5400000" sx="96000" sy="96000" rotWithShape="0">
               <a:srgbClr val="000000">
-                <a:alpha val="35000"/>
-              </a:srgbClr>
-            </a:outerShdw>
-          </a:effectLst>
-        </a:effectStyle>
-        <a:effectStyle>
-          <a:effectLst>
-            <a:outerShdw blurRad="40000" dist="23000" dir="5400000" rotWithShape="0">
-              <a:srgbClr val="000000">
-                <a:alpha val="35000"/>
+                <a:alpha val="48000"/>
               </a:srgbClr>
             </a:outerShdw>
           </a:effectLst>
@@ -4631,12 +5299,12 @@
             <a:camera prst="orthographicFront">
               <a:rot lat="0" lon="0" rev="0"/>
             </a:camera>
-            <a:lightRig rig="threePt" dir="t">
-              <a:rot lat="0" lon="0" rev="1200000"/>
+            <a:lightRig rig="balanced" dir="t">
+              <a:rot lat="0" lon="0" rev="1080000"/>
             </a:lightRig>
           </a:scene3d>
           <a:sp3d>
-            <a:bevelT w="63500" h="25400"/>
+            <a:bevelT w="38100" h="12700" prst="softRound"/>
           </a:sp3d>
         </a:effectStyle>
       </a:effectStyleLst>
@@ -4644,44 +5312,21 @@
         <a:solidFill>
           <a:schemeClr val="phClr"/>
         </a:solidFill>
+        <a:solidFill>
+          <a:schemeClr val="phClr"/>
+        </a:solidFill>
         <a:gradFill rotWithShape="1">
           <a:gsLst>
             <a:gs pos="0">
               <a:schemeClr val="phClr">
-                <a:tint val="40000"/>
-                <a:satMod val="350000"/>
-              </a:schemeClr>
-            </a:gs>
-            <a:gs pos="40000">
-              <a:schemeClr val="phClr">
-                <a:tint val="45000"/>
-                <a:shade val="99000"/>
-                <a:satMod val="350000"/>
+                <a:tint val="94000"/>
+                <a:satMod val="80000"/>
+                <a:lumMod val="106000"/>
               </a:schemeClr>
             </a:gs>
             <a:gs pos="100000">
               <a:schemeClr val="phClr">
-                <a:shade val="20000"/>
-                <a:satMod val="255000"/>
-              </a:schemeClr>
-            </a:gs>
-          </a:gsLst>
-          <a:path path="circle">
-            <a:fillToRect l="50000" t="-80000" r="50000" b="180000"/>
-          </a:path>
-        </a:gradFill>
-        <a:gradFill rotWithShape="1">
-          <a:gsLst>
-            <a:gs pos="0">
-              <a:schemeClr val="phClr">
-                <a:tint val="80000"/>
-                <a:satMod val="300000"/>
-              </a:schemeClr>
-            </a:gs>
-            <a:gs pos="100000">
-              <a:schemeClr val="phClr">
-                <a:shade val="30000"/>
-                <a:satMod val="200000"/>
+                <a:shade val="80000"/>
               </a:schemeClr>
             </a:gs>
           </a:gsLst>
@@ -4692,46 +5337,12 @@
       </a:bgFillStyleLst>
     </a:fmtScheme>
   </a:themeElements>
-  <a:objectDefaults>
-    <a:spDef>
-      <a:spPr/>
-      <a:bodyPr/>
-      <a:lstStyle/>
-      <a:style>
-        <a:lnRef idx="1">
-          <a:schemeClr val="accent1"/>
-        </a:lnRef>
-        <a:fillRef idx="3">
-          <a:schemeClr val="accent1"/>
-        </a:fillRef>
-        <a:effectRef idx="2">
-          <a:schemeClr val="accent1"/>
-        </a:effectRef>
-        <a:fontRef idx="minor">
-          <a:schemeClr val="lt1"/>
-        </a:fontRef>
-      </a:style>
-    </a:spDef>
-    <a:lnDef>
-      <a:spPr/>
-      <a:bodyPr/>
-      <a:lstStyle/>
-      <a:style>
-        <a:lnRef idx="2">
-          <a:schemeClr val="accent1"/>
-        </a:lnRef>
-        <a:fillRef idx="0">
-          <a:schemeClr val="accent1"/>
-        </a:fillRef>
-        <a:effectRef idx="1">
-          <a:schemeClr val="accent1"/>
-        </a:effectRef>
-        <a:fontRef idx="minor">
-          <a:schemeClr val="tx1"/>
-        </a:fontRef>
-      </a:style>
-    </a:lnDef>
-  </a:objectDefaults>
+  <a:objectDefaults/>
   <a:extraClrSchemeLst/>
+  <a:extLst>
+    <a:ext uri="{05A4C25C-085E-4340-85A3-A5531E510DB2}">
+      <thm15:themeFamily xmlns:thm15="http://schemas.microsoft.com/office/thememl/2012/main" name="Gallery" id="{BBFCD31E-59A1-489D-B089-A3EAD7CAE12E}" vid="{F5E91637-A7B6-4E27-B710-77DA7014EE1E}"/>
+    </a:ext>
+  </a:extLst>
 </a:theme>
 </file>
</xml_diff>